<commit_message>
refactor(deck): ground slides in crawl data, rename to Current Students Website
- Slide 3 (landscape): 4 estate stat cards (1,173/300/116/1,589 pp), plain-language
  crawl method intro, 4 overlap themes (careers/mentoring/course info/alumni handoff)
  with specific numbers; removes scope note
- Slide 4 (Venn): label "Central hub" → "Current Students Website"
- Slide 5 (matrix): column header renamed; last two rows promoted from indicative
  italic to live data (0 alumni links, 529 study.unimelb back-links); indicative
  footer removed; To discuss bar repositioned
- Slide 6 (discussion): right panel "AREAS TO DISCUSS" → "WHAT THE DATA SHOWS" with
  5 concrete crawl findings (mentoring, careers, graduation exit, reverse funnel,
  scholarships) replacing 6 generic topic labels
- Appendix B: column header renamed to match

Co-Authored-By: Claude Sonnet 4.6 <noreply@anthropic.com>
</commit_message>
<xml_diff>
--- a/discussion-deck/Current-Students-EndToEnd-Discussion.pptx
+++ b/discussion-deck/Current-Students-EndToEnd-Discussion.pptx
@@ -953,7 +953,7 @@
           <a:p>
             <a:r>
               <a:rPr lang="en-US" dirty="0"/>
-              <a:t>Scale-setting (~2 min), don't dwell. The point is breadth: 13 sites, 6 address patterns — and this is only the current-students slice. Reinforce the descriptive note — we're not grading anyone's site today.</a:t>
+              <a:t>Scale-setting and method (~3 min). Explain the crawl in one sentence: an automated browser, every public page, tagged by topic. The four stat cards cover all four parts of the estate. The four themes below are the main overlaps the data surfaced. Don't dwell — the discussion slides go deeper. We're not grading anyone's site today.</a:t>
             </a:r>
             <a:endParaRPr lang="en-US" dirty="0"/>
           </a:p>
@@ -1129,7 +1129,7 @@
           <a:p>
             <a:r>
               <a:rPr lang="en-US" dirty="0"/>
-              <a:t>Walk the rows quickly (~5 min). Don't defend the marks — invite corrections and mark them live. 'Cross-linked?' means: do the central and faculty versions point to each other. Note the bottom two rows are indicative — full audit of study.unimelb and alumni coming. The goal is a shared picture before we open the discussion.</a:t>
+              <a:t>Walk the rows quickly (~5 min). Don't defend the marks — invite corrections and mark them live. 'Cross-linked?' means: do the current-students-website and faculty versions point to each other. Alumni and study.unimelb rows are from the June 2026 crawl — 0 links from current-student pages to alumni is confirmed. The goal is a shared picture before we open the discussion.</a:t>
             </a:r>
             <a:endParaRPr lang="en-US" dirty="0"/>
           </a:p>
@@ -1217,7 +1217,7 @@
           <a:p>
             <a:r>
               <a:rPr lang="en-US" dirty="0"/>
-              <a:t>Open the room (~15 min). Work through the areas on the right — use the list as a prompt, not a rigid sequence. For each: is there overlap? Is it helpful? Is someone already working on it? Capture themes on the next slide. Keep out of solution mode — we're mapping the territory, not resolving it today.</a:t>
+              <a:t>Data-driven discussion (~15 min). Each finding on the right is from the June 2026 crawl — use them as conversation starters, not a rigid sequence. For each: is this the right picture? What explains it? Is someone already working on it? Capture themes on the next slide. Keep out of solution mode — we're mapping the territory, not resolving it today.</a:t>
             </a:r>
             <a:endParaRPr lang="en-US" dirty="0"/>
           </a:p>
@@ -8205,7 +8205,7 @@
                           <a:ea typeface="Source Sans 3" pitchFamily="34" charset="-122"/>
                           <a:cs typeface="Source Sans 3" pitchFamily="34" charset="-120"/>
                         </a:rPr>
-                        <a:t>Hub</a:t>
+                        <a:t>Current Students</a:t>
                       </a:r>
                       <a:endParaRPr lang="en-US" sz="1100" dirty="0">
                         <a:latin typeface="Source Sans 3" charset="0"/>
@@ -8226,7 +8226,7 @@
                           <a:ea typeface="Source Sans 3" pitchFamily="34" charset="-122"/>
                           <a:cs typeface="Source Sans 3" pitchFamily="34" charset="-120"/>
                         </a:rPr>
-                        <a:t>(students.)</a:t>
+                        <a:t>Website</a:t>
                       </a:r>
                       <a:endParaRPr lang="en-US" sz="1100" dirty="0">
                         <a:latin typeface="Source Sans 3" charset="0"/>
@@ -12226,7 +12226,7 @@
         <p:spPr>
           <a:xfrm>
             <a:off x="566928" y="1325880"/>
-            <a:ext cx="10881360" cy="914400"/>
+            <a:ext cx="10881360" cy="658368"/>
           </a:xfrm>
           <a:prstGeom prst="rect">
             <a:avLst/>
@@ -12245,7 +12245,7 @@
               <a:buNone/>
             </a:pPr>
             <a:r>
-              <a:rPr lang="en-US" sz="1550" dirty="0">
+              <a:rPr lang="en-US" sz="1450" dirty="0">
                 <a:solidFill>
                   <a:srgbClr val="1C1C28"/>
                 </a:solidFill>
@@ -12253,9 +12253,9 @@
                 <a:ea typeface="Source Sans 3" pitchFamily="34" charset="-122"/>
                 <a:cs typeface="Source Sans 3" pitchFamily="34" charset="-120"/>
               </a:rPr>
-              <a:t>A full content scan of the current-students estate — the central hub plus nine faculties and three schools. The same user need is often served in more than one place; some content is genuinely discipline-specific, and some is shared.</a:t>
+              <a:t>In June 2026, an automated browser visited every publicly reachable page across the University's web estate — following links the same way a user would. Each page was read, classified and tagged by topic. The numbers below come from that crawl.</a:t>
             </a:r>
-            <a:endParaRPr lang="en-US" sz="1550" dirty="0"/>
+            <a:endParaRPr lang="en-US" sz="1450" dirty="0"/>
           </a:p>
         </p:txBody>
       </p:sp>
@@ -12267,8 +12267,8 @@
         </p:nvSpPr>
         <p:spPr>
           <a:xfrm>
-            <a:off x="566928" y="2606040"/>
-            <a:ext cx="3529584" cy="1828800"/>
+            <a:off x="566928" y="2084832"/>
+            <a:ext cx="2651760" cy="1572768"/>
           </a:xfrm>
           <a:prstGeom prst="rect">
             <a:avLst/>
@@ -12287,8 +12287,8 @@
         </p:nvSpPr>
         <p:spPr>
           <a:xfrm>
-            <a:off x="566928" y="2606040"/>
-            <a:ext cx="3529584" cy="91440"/>
+            <a:off x="566928" y="2084832"/>
+            <a:ext cx="2651760" cy="91440"/>
           </a:xfrm>
           <a:prstGeom prst="rect">
             <a:avLst/>
@@ -12307,8 +12307,8 @@
         </p:nvSpPr>
         <p:spPr>
           <a:xfrm>
-            <a:off x="566928" y="2834640"/>
-            <a:ext cx="3529584" cy="914400"/>
+            <a:off x="566928" y="2212848"/>
+            <a:ext cx="2651760" cy="804672"/>
           </a:xfrm>
           <a:prstGeom prst="rect">
             <a:avLst/>
@@ -12324,7 +12324,7 @@
               <a:buNone/>
             </a:pPr>
             <a:r>
-              <a:rPr lang="en-US" sz="5200" b="1" dirty="0">
+              <a:rPr lang="en-US" sz="4400" b="1" dirty="0">
                 <a:solidFill>
                   <a:srgbClr val="000F46"/>
                 </a:solidFill>
@@ -12332,9 +12332,9 @@
                 <a:ea typeface="Fraunces" pitchFamily="34" charset="-122"/>
                 <a:cs typeface="Fraunces" pitchFamily="34" charset="-120"/>
               </a:rPr>
-              <a:t>1,161</a:t>
+              <a:t>1,173</a:t>
             </a:r>
-            <a:endParaRPr lang="en-US" sz="5200" dirty="0"/>
+            <a:endParaRPr lang="en-US" sz="4400" dirty="0"/>
           </a:p>
         </p:txBody>
       </p:sp>
@@ -12346,8 +12346,8 @@
         </p:nvSpPr>
         <p:spPr>
           <a:xfrm>
-            <a:off x="795528" y="3749040"/>
-            <a:ext cx="3072384" cy="548640"/>
+            <a:off x="658368" y="3035808"/>
+            <a:ext cx="2468880" cy="512064"/>
           </a:xfrm>
           <a:prstGeom prst="rect">
             <a:avLst/>
@@ -12360,10 +12360,13 @@
           <a:lstStyle/>
           <a:p>
             <a:pPr algn="ctr" indent="0" marL="0">
+              <a:lnSpc>
+                <a:spcPct val="110000"/>
+              </a:lnSpc>
               <a:buNone/>
             </a:pPr>
             <a:r>
-              <a:rPr lang="en-US" sz="1300" dirty="0">
+              <a:rPr lang="en-US" sz="1150" dirty="0">
                 <a:solidFill>
                   <a:srgbClr val="5B5B6B"/>
                 </a:solidFill>
@@ -12371,9 +12374,29 @@
                 <a:ea typeface="Source Sans 3" pitchFamily="34" charset="-122"/>
                 <a:cs typeface="Source Sans 3" pitchFamily="34" charset="-120"/>
               </a:rPr>
-              <a:t>pages of current-students content</a:t>
+              <a:t>Current Students Website</a:t>
             </a:r>
-            <a:endParaRPr lang="en-US" sz="1300" dirty="0"/>
+            <a:endParaRPr lang="en-US" sz="1150" dirty="0"/>
+          </a:p>
+          <a:p>
+            <a:pPr algn="ctr" indent="0" marL="0">
+              <a:lnSpc>
+                <a:spcPct val="110000"/>
+              </a:lnSpc>
+              <a:buNone/>
+            </a:pPr>
+            <a:r>
+              <a:rPr lang="en-US" sz="1150" dirty="0">
+                <a:solidFill>
+                  <a:srgbClr val="5B5B6B"/>
+                </a:solidFill>
+                <a:latin typeface="Source Sans 3" pitchFamily="34" charset="0"/>
+                <a:ea typeface="Source Sans 3" pitchFamily="34" charset="-122"/>
+                <a:cs typeface="Source Sans 3" pitchFamily="34" charset="-120"/>
+              </a:rPr>
+              <a:t>+ 12 faculty / school sites</a:t>
+            </a:r>
+            <a:endParaRPr lang="en-US" sz="1150" dirty="0"/>
           </a:p>
         </p:txBody>
       </p:sp>
@@ -12385,8 +12408,8 @@
         </p:nvSpPr>
         <p:spPr>
           <a:xfrm>
-            <a:off x="4334256" y="2606040"/>
-            <a:ext cx="3529584" cy="1828800"/>
+            <a:off x="3364992" y="2084832"/>
+            <a:ext cx="2651760" cy="1572768"/>
           </a:xfrm>
           <a:prstGeom prst="rect">
             <a:avLst/>
@@ -12405,8 +12428,8 @@
         </p:nvSpPr>
         <p:spPr>
           <a:xfrm>
-            <a:off x="4334256" y="2606040"/>
-            <a:ext cx="3529584" cy="91440"/>
+            <a:off x="3364992" y="2084832"/>
+            <a:ext cx="2651760" cy="91440"/>
           </a:xfrm>
           <a:prstGeom prst="rect">
             <a:avLst/>
@@ -12425,8 +12448,8 @@
         </p:nvSpPr>
         <p:spPr>
           <a:xfrm>
-            <a:off x="4334256" y="2834640"/>
-            <a:ext cx="3529584" cy="914400"/>
+            <a:off x="3364992" y="2212848"/>
+            <a:ext cx="2651760" cy="804672"/>
           </a:xfrm>
           <a:prstGeom prst="rect">
             <a:avLst/>
@@ -12442,7 +12465,7 @@
               <a:buNone/>
             </a:pPr>
             <a:r>
-              <a:rPr lang="en-US" sz="5200" b="1" dirty="0">
+              <a:rPr lang="en-US" sz="4400" b="1" dirty="0">
                 <a:solidFill>
                   <a:srgbClr val="000F46"/>
                 </a:solidFill>
@@ -12450,9 +12473,9 @@
                 <a:ea typeface="Fraunces" pitchFamily="34" charset="-122"/>
                 <a:cs typeface="Fraunces" pitchFamily="34" charset="-120"/>
               </a:rPr>
-              <a:t>13</a:t>
+              <a:t>300</a:t>
             </a:r>
-            <a:endParaRPr lang="en-US" sz="5200" dirty="0"/>
+            <a:endParaRPr lang="en-US" sz="4400" dirty="0"/>
           </a:p>
         </p:txBody>
       </p:sp>
@@ -12464,8 +12487,8 @@
         </p:nvSpPr>
         <p:spPr>
           <a:xfrm>
-            <a:off x="4562856" y="3749040"/>
-            <a:ext cx="3072384" cy="548640"/>
+            <a:off x="3456432" y="3035808"/>
+            <a:ext cx="2468880" cy="512064"/>
           </a:xfrm>
           <a:prstGeom prst="rect">
             <a:avLst/>
@@ -12478,10 +12501,13 @@
           <a:lstStyle/>
           <a:p>
             <a:pPr algn="ctr" indent="0" marL="0">
+              <a:lnSpc>
+                <a:spcPct val="110000"/>
+              </a:lnSpc>
               <a:buNone/>
             </a:pPr>
             <a:r>
-              <a:rPr lang="en-US" sz="1300" dirty="0">
+              <a:rPr lang="en-US" sz="1150" dirty="0">
                 <a:solidFill>
                   <a:srgbClr val="5B5B6B"/>
                 </a:solidFill>
@@ -12489,9 +12515,29 @@
                 <a:ea typeface="Source Sans 3" pitchFamily="34" charset="-122"/>
                 <a:cs typeface="Source Sans 3" pitchFamily="34" charset="-120"/>
               </a:rPr>
-              <a:t>separate websites</a:t>
+              <a:t>study.unimelb</a:t>
             </a:r>
-            <a:endParaRPr lang="en-US" sz="1300" dirty="0"/>
+            <a:endParaRPr lang="en-US" sz="1150" dirty="0"/>
+          </a:p>
+          <a:p>
+            <a:pPr algn="ctr" indent="0" marL="0">
+              <a:lnSpc>
+                <a:spcPct val="110000"/>
+              </a:lnSpc>
+              <a:buNone/>
+            </a:pPr>
+            <a:r>
+              <a:rPr lang="en-US" sz="1150" dirty="0">
+                <a:solidFill>
+                  <a:srgbClr val="5B5B6B"/>
+                </a:solidFill>
+                <a:latin typeface="Source Sans 3" pitchFamily="34" charset="0"/>
+                <a:ea typeface="Source Sans 3" pitchFamily="34" charset="-122"/>
+                <a:cs typeface="Source Sans 3" pitchFamily="34" charset="-120"/>
+              </a:rPr>
+              <a:t>prospective students</a:t>
+            </a:r>
+            <a:endParaRPr lang="en-US" sz="1150" dirty="0"/>
           </a:p>
         </p:txBody>
       </p:sp>
@@ -12503,8 +12549,8 @@
         </p:nvSpPr>
         <p:spPr>
           <a:xfrm>
-            <a:off x="8101584" y="2606040"/>
-            <a:ext cx="3529584" cy="1828800"/>
+            <a:off x="6163056" y="2084832"/>
+            <a:ext cx="2651760" cy="1572768"/>
           </a:xfrm>
           <a:prstGeom prst="rect">
             <a:avLst/>
@@ -12523,8 +12569,8 @@
         </p:nvSpPr>
         <p:spPr>
           <a:xfrm>
-            <a:off x="8101584" y="2606040"/>
-            <a:ext cx="3529584" cy="91440"/>
+            <a:off x="6163056" y="2084832"/>
+            <a:ext cx="2651760" cy="91440"/>
           </a:xfrm>
           <a:prstGeom prst="rect">
             <a:avLst/>
@@ -12543,8 +12589,8 @@
         </p:nvSpPr>
         <p:spPr>
           <a:xfrm>
-            <a:off x="8101584" y="2834640"/>
-            <a:ext cx="3529584" cy="914400"/>
+            <a:off x="6163056" y="2212848"/>
+            <a:ext cx="2651760" cy="804672"/>
           </a:xfrm>
           <a:prstGeom prst="rect">
             <a:avLst/>
@@ -12560,7 +12606,7 @@
               <a:buNone/>
             </a:pPr>
             <a:r>
-              <a:rPr lang="en-US" sz="5200" b="1" dirty="0">
+              <a:rPr lang="en-US" sz="4400" b="1" dirty="0">
                 <a:solidFill>
                   <a:srgbClr val="000F46"/>
                 </a:solidFill>
@@ -12568,9 +12614,9 @@
                 <a:ea typeface="Fraunces" pitchFamily="34" charset="-122"/>
                 <a:cs typeface="Fraunces" pitchFamily="34" charset="-120"/>
               </a:rPr>
-              <a:t>6</a:t>
+              <a:t>116</a:t>
             </a:r>
-            <a:endParaRPr lang="en-US" sz="5200" dirty="0"/>
+            <a:endParaRPr lang="en-US" sz="4400" dirty="0"/>
           </a:p>
         </p:txBody>
       </p:sp>
@@ -12582,8 +12628,110 @@
         </p:nvSpPr>
         <p:spPr>
           <a:xfrm>
-            <a:off x="8330184" y="3749040"/>
-            <a:ext cx="3072384" cy="548640"/>
+            <a:off x="6254496" y="3035808"/>
+            <a:ext cx="2468880" cy="512064"/>
+          </a:xfrm>
+          <a:prstGeom prst="rect">
+            <a:avLst/>
+          </a:prstGeom>
+          <a:noFill/>
+          <a:ln/>
+        </p:spPr>
+        <p:txBody>
+          <a:bodyPr wrap="square" lIns="0" tIns="0" rIns="0" bIns="0" rtlCol="0" anchor="ctr"/>
+          <a:lstStyle/>
+          <a:p>
+            <a:pPr algn="ctr" indent="0" marL="0">
+              <a:lnSpc>
+                <a:spcPct val="110000"/>
+              </a:lnSpc>
+              <a:buNone/>
+            </a:pPr>
+            <a:r>
+              <a:rPr lang="en-US" sz="1150" dirty="0">
+                <a:solidFill>
+                  <a:srgbClr val="5B5B6B"/>
+                </a:solidFill>
+                <a:latin typeface="Source Sans 3" pitchFamily="34" charset="0"/>
+                <a:ea typeface="Source Sans 3" pitchFamily="34" charset="-122"/>
+                <a:cs typeface="Source Sans 3" pitchFamily="34" charset="-120"/>
+              </a:rPr>
+              <a:t>alumni.unimelb</a:t>
+            </a:r>
+            <a:endParaRPr lang="en-US" sz="1150" dirty="0"/>
+          </a:p>
+          <a:p>
+            <a:pPr algn="ctr" indent="0" marL="0">
+              <a:lnSpc>
+                <a:spcPct val="110000"/>
+              </a:lnSpc>
+              <a:buNone/>
+            </a:pPr>
+            <a:r>
+              <a:rPr lang="en-US" sz="1150" dirty="0">
+                <a:solidFill>
+                  <a:srgbClr val="5B5B6B"/>
+                </a:solidFill>
+                <a:latin typeface="Source Sans 3" pitchFamily="34" charset="0"/>
+                <a:ea typeface="Source Sans 3" pitchFamily="34" charset="-122"/>
+                <a:cs typeface="Source Sans 3" pitchFamily="34" charset="-120"/>
+              </a:rPr>
+              <a:t>graduate community</a:t>
+            </a:r>
+            <a:endParaRPr lang="en-US" sz="1150" dirty="0"/>
+          </a:p>
+        </p:txBody>
+      </p:sp>
+      <p:sp>
+        <p:nvSpPr>
+          <p:cNvPr id="19" name="Shape 17"/>
+          <p:cNvSpPr/>
+          <p:nvPr/>
+        </p:nvSpPr>
+        <p:spPr>
+          <a:xfrm>
+            <a:off x="8961120" y="2084832"/>
+            <a:ext cx="2651760" cy="1572768"/>
+          </a:xfrm>
+          <a:prstGeom prst="rect">
+            <a:avLst/>
+          </a:prstGeom>
+          <a:solidFill>
+            <a:srgbClr val="F4F4F4"/>
+          </a:solidFill>
+          <a:ln/>
+        </p:spPr>
+      </p:sp>
+      <p:sp>
+        <p:nvSpPr>
+          <p:cNvPr id="20" name="Shape 18"/>
+          <p:cNvSpPr/>
+          <p:nvPr/>
+        </p:nvSpPr>
+        <p:spPr>
+          <a:xfrm>
+            <a:off x="8961120" y="2084832"/>
+            <a:ext cx="2651760" cy="91440"/>
+          </a:xfrm>
+          <a:prstGeom prst="rect">
+            <a:avLst/>
+          </a:prstGeom>
+          <a:solidFill>
+            <a:srgbClr val="46C8F0"/>
+          </a:solidFill>
+          <a:ln/>
+        </p:spPr>
+      </p:sp>
+      <p:sp>
+        <p:nvSpPr>
+          <p:cNvPr id="21" name="Text 19"/>
+          <p:cNvSpPr/>
+          <p:nvPr/>
+        </p:nvSpPr>
+        <p:spPr>
+          <a:xfrm>
+            <a:off x="8961120" y="2212848"/>
+            <a:ext cx="2651760" cy="804672"/>
           </a:xfrm>
           <a:prstGeom prst="rect">
             <a:avLst/>
@@ -12599,30 +12747,30 @@
               <a:buNone/>
             </a:pPr>
             <a:r>
-              <a:rPr lang="en-US" sz="1300" dirty="0">
+              <a:rPr lang="en-US" sz="4400" b="1" dirty="0">
                 <a:solidFill>
-                  <a:srgbClr val="5B5B6B"/>
+                  <a:srgbClr val="000F46"/>
                 </a:solidFill>
-                <a:latin typeface="Source Sans 3" pitchFamily="34" charset="0"/>
-                <a:ea typeface="Source Sans 3" pitchFamily="34" charset="-122"/>
-                <a:cs typeface="Source Sans 3" pitchFamily="34" charset="-120"/>
+                <a:latin typeface="Fraunces" pitchFamily="34" charset="0"/>
+                <a:ea typeface="Fraunces" pitchFamily="34" charset="-122"/>
+                <a:cs typeface="Fraunces" pitchFamily="34" charset="-120"/>
               </a:rPr>
-              <a:t>different web-address patterns</a:t>
+              <a:t>1,589</a:t>
             </a:r>
-            <a:endParaRPr lang="en-US" sz="1300" dirty="0"/>
+            <a:endParaRPr lang="en-US" sz="4400" dirty="0"/>
           </a:p>
         </p:txBody>
       </p:sp>
       <p:sp>
         <p:nvSpPr>
-          <p:cNvPr id="19" name="Text 17"/>
+          <p:cNvPr id="22" name="Text 20"/>
           <p:cNvSpPr/>
           <p:nvPr/>
         </p:nvSpPr>
         <p:spPr>
           <a:xfrm>
-            <a:off x="566928" y="4754880"/>
-            <a:ext cx="10881360" cy="822960"/>
+            <a:off x="9052560" y="3035808"/>
+            <a:ext cx="2468880" cy="512064"/>
           </a:xfrm>
           <a:prstGeom prst="rect">
             <a:avLst/>
@@ -12634,37 +12782,77 @@
           <a:bodyPr wrap="square" lIns="0" tIns="0" rIns="0" bIns="0" rtlCol="0" anchor="ctr"/>
           <a:lstStyle/>
           <a:p>
-            <a:pPr indent="0" marL="0">
+            <a:pPr algn="ctr" indent="0" marL="0">
               <a:lnSpc>
-                <a:spcPct val="118000"/>
+                <a:spcPct val="110000"/>
               </a:lnSpc>
               <a:buNone/>
             </a:pPr>
             <a:r>
-              <a:rPr lang="en-US" sz="1250" i="1" dirty="0">
+              <a:rPr lang="en-US" sz="1150" dirty="0">
                 <a:solidFill>
-                  <a:srgbClr val="000B34"/>
+                  <a:srgbClr val="5B5B6B"/>
                 </a:solidFill>
                 <a:latin typeface="Source Sans 3" pitchFamily="34" charset="0"/>
                 <a:ea typeface="Source Sans 3" pitchFamily="34" charset="-122"/>
                 <a:cs typeface="Source Sans 3" pitchFamily="34" charset="-120"/>
               </a:rPr>
-              <a:t>Central hub · Architecture, Building &amp; Planning · Arts · Business &amp; Economics · Education · Engineering &amp; IT · Fine Arts &amp; Music · Law · Medicine, Dentistry &amp; Health Sciences · Science  —  plus separate Business School, Biomedical Sciences and Dental school sites.</a:t>
+              <a:t>total pages</a:t>
             </a:r>
-            <a:endParaRPr lang="en-US" sz="1250" dirty="0"/>
+            <a:endParaRPr lang="en-US" sz="1150" dirty="0"/>
+          </a:p>
+          <a:p>
+            <a:pPr algn="ctr" indent="0" marL="0">
+              <a:lnSpc>
+                <a:spcPct val="110000"/>
+              </a:lnSpc>
+              <a:buNone/>
+            </a:pPr>
+            <a:r>
+              <a:rPr lang="en-US" sz="1150" dirty="0">
+                <a:solidFill>
+                  <a:srgbClr val="5B5B6B"/>
+                </a:solidFill>
+                <a:latin typeface="Source Sans 3" pitchFamily="34" charset="0"/>
+                <a:ea typeface="Source Sans 3" pitchFamily="34" charset="-122"/>
+                <a:cs typeface="Source Sans 3" pitchFamily="34" charset="-120"/>
+              </a:rPr>
+              <a:t>reviewed</a:t>
+            </a:r>
+            <a:endParaRPr lang="en-US" sz="1150" dirty="0"/>
           </a:p>
         </p:txBody>
       </p:sp>
       <p:sp>
         <p:nvSpPr>
-          <p:cNvPr id="20" name="Text 18"/>
+          <p:cNvPr id="23" name="Shape 21"/>
           <p:cNvSpPr/>
           <p:nvPr/>
         </p:nvSpPr>
         <p:spPr>
           <a:xfrm>
-            <a:off x="566928" y="5669280"/>
-            <a:ext cx="10881360" cy="320040"/>
+            <a:off x="566928" y="3767328"/>
+            <a:ext cx="2651760" cy="64008"/>
+          </a:xfrm>
+          <a:prstGeom prst="rect">
+            <a:avLst/>
+          </a:prstGeom>
+          <a:solidFill>
+            <a:srgbClr val="46C8F0"/>
+          </a:solidFill>
+          <a:ln/>
+        </p:spPr>
+      </p:sp>
+      <p:sp>
+        <p:nvSpPr>
+          <p:cNvPr id="24" name="Text 22"/>
+          <p:cNvSpPr/>
+          <p:nvPr/>
+        </p:nvSpPr>
+        <p:spPr>
+          <a:xfrm>
+            <a:off x="566928" y="3858768"/>
+            <a:ext cx="2651760" cy="274320"/>
           </a:xfrm>
           <a:prstGeom prst="rect">
             <a:avLst/>
@@ -12680,17 +12868,404 @@
               <a:buNone/>
             </a:pPr>
             <a:r>
-              <a:rPr lang="en-US" sz="950" dirty="0">
+              <a:rPr lang="en-US" sz="1200" b="1" dirty="0">
+                <a:solidFill>
+                  <a:srgbClr val="000F46"/>
+                </a:solidFill>
+                <a:latin typeface="Source Sans 3" pitchFamily="34" charset="0"/>
+                <a:ea typeface="Source Sans 3" pitchFamily="34" charset="-122"/>
+                <a:cs typeface="Source Sans 3" pitchFamily="34" charset="-120"/>
+              </a:rPr>
+              <a:t>Careers</a:t>
+            </a:r>
+            <a:endParaRPr lang="en-US" sz="1200" dirty="0"/>
+          </a:p>
+        </p:txBody>
+      </p:sp>
+      <p:sp>
+        <p:nvSpPr>
+          <p:cNvPr id="25" name="Text 23"/>
+          <p:cNvSpPr/>
+          <p:nvPr/>
+        </p:nvSpPr>
+        <p:spPr>
+          <a:xfrm>
+            <a:off x="566928" y="4169664"/>
+            <a:ext cx="2651760" cy="932688"/>
+          </a:xfrm>
+          <a:prstGeom prst="rect">
+            <a:avLst/>
+          </a:prstGeom>
+          <a:noFill/>
+          <a:ln/>
+        </p:spPr>
+        <p:txBody>
+          <a:bodyPr wrap="square" lIns="0" tIns="0" rIns="0" bIns="0" rtlCol="0" anchor="ctr"/>
+          <a:lstStyle/>
+          <a:p>
+            <a:pPr indent="0" marL="0">
+              <a:lnSpc>
+                <a:spcPct val="114000"/>
+              </a:lnSpc>
+              <a:buNone/>
+            </a:pPr>
+            <a:r>
+              <a:rPr lang="en-US" sz="1100" dirty="0">
                 <a:solidFill>
                   <a:srgbClr val="5B5B6B"/>
                 </a:solidFill>
-                <a:latin typeface="Source Code Pro" pitchFamily="34" charset="0"/>
-                <a:ea typeface="Source Code Pro" pitchFamily="34" charset="-122"/>
-                <a:cs typeface="Source Code Pro" pitchFamily="34" charset="-120"/>
+                <a:latin typeface="Source Sans 3" pitchFamily="34" charset="0"/>
+                <a:ea typeface="Source Sans 3" pitchFamily="34" charset="-122"/>
+                <a:cs typeface="Source Sans 3" pitchFamily="34" charset="-120"/>
               </a:rPr>
-              <a:t>Scope note: this scan covers the current-students sections. The broader picture also includes study.unimelb.edu.au and the University's alumni estate.</a:t>
+              <a:t>4 parallel presences — central, 8 faculties, study.unimelb, alumni. No cross-links in any direction.</a:t>
             </a:r>
-            <a:endParaRPr lang="en-US" sz="950" dirty="0"/>
+            <a:endParaRPr lang="en-US" sz="1100" dirty="0"/>
+          </a:p>
+        </p:txBody>
+      </p:sp>
+      <p:sp>
+        <p:nvSpPr>
+          <p:cNvPr id="26" name="Shape 24"/>
+          <p:cNvSpPr/>
+          <p:nvPr/>
+        </p:nvSpPr>
+        <p:spPr>
+          <a:xfrm>
+            <a:off x="3364992" y="3767328"/>
+            <a:ext cx="2651760" cy="64008"/>
+          </a:xfrm>
+          <a:prstGeom prst="rect">
+            <a:avLst/>
+          </a:prstGeom>
+          <a:solidFill>
+            <a:srgbClr val="46C8F0"/>
+          </a:solidFill>
+          <a:ln/>
+        </p:spPr>
+      </p:sp>
+      <p:sp>
+        <p:nvSpPr>
+          <p:cNvPr id="27" name="Text 25"/>
+          <p:cNvSpPr/>
+          <p:nvPr/>
+        </p:nvSpPr>
+        <p:spPr>
+          <a:xfrm>
+            <a:off x="3364992" y="3858768"/>
+            <a:ext cx="2651760" cy="274320"/>
+          </a:xfrm>
+          <a:prstGeom prst="rect">
+            <a:avLst/>
+          </a:prstGeom>
+          <a:noFill/>
+          <a:ln/>
+        </p:spPr>
+        <p:txBody>
+          <a:bodyPr wrap="square" lIns="0" tIns="0" rIns="0" bIns="0" rtlCol="0" anchor="ctr"/>
+          <a:lstStyle/>
+          <a:p>
+            <a:pPr indent="0" marL="0">
+              <a:buNone/>
+            </a:pPr>
+            <a:r>
+              <a:rPr lang="en-US" sz="1200" b="1" dirty="0">
+                <a:solidFill>
+                  <a:srgbClr val="000F46"/>
+                </a:solidFill>
+                <a:latin typeface="Source Sans 3" pitchFamily="34" charset="0"/>
+                <a:ea typeface="Source Sans 3" pitchFamily="34" charset="-122"/>
+                <a:cs typeface="Source Sans 3" pitchFamily="34" charset="-120"/>
+              </a:rPr>
+              <a:t>Mentoring</a:t>
+            </a:r>
+            <a:endParaRPr lang="en-US" sz="1200" dirty="0"/>
+          </a:p>
+        </p:txBody>
+      </p:sp>
+      <p:sp>
+        <p:nvSpPr>
+          <p:cNvPr id="28" name="Text 26"/>
+          <p:cNvSpPr/>
+          <p:nvPr/>
+        </p:nvSpPr>
+        <p:spPr>
+          <a:xfrm>
+            <a:off x="3364992" y="4169664"/>
+            <a:ext cx="2651760" cy="932688"/>
+          </a:xfrm>
+          <a:prstGeom prst="rect">
+            <a:avLst/>
+          </a:prstGeom>
+          <a:noFill/>
+          <a:ln/>
+        </p:spPr>
+        <p:txBody>
+          <a:bodyPr wrap="square" lIns="0" tIns="0" rIns="0" bIns="0" rtlCol="0" anchor="ctr"/>
+          <a:lstStyle/>
+          <a:p>
+            <a:pPr indent="0" marL="0">
+              <a:lnSpc>
+                <a:spcPct val="114000"/>
+              </a:lnSpc>
+              <a:buNone/>
+            </a:pPr>
+            <a:r>
+              <a:rPr lang="en-US" sz="1100" dirty="0">
+                <a:solidFill>
+                  <a:srgbClr val="5B5B6B"/>
+                </a:solidFill>
+                <a:latin typeface="Source Sans 3" pitchFamily="34" charset="0"/>
+                <a:ea typeface="Source Sans 3" pitchFamily="34" charset="-122"/>
+                <a:cs typeface="Source Sans 3" pitchFamily="34" charset="-120"/>
+              </a:rPr>
+              <a:t>12 faculty alumni programs matching student programs on all faculties. Neither side links to the other.</a:t>
+            </a:r>
+            <a:endParaRPr lang="en-US" sz="1100" dirty="0"/>
+          </a:p>
+        </p:txBody>
+      </p:sp>
+      <p:sp>
+        <p:nvSpPr>
+          <p:cNvPr id="29" name="Shape 27"/>
+          <p:cNvSpPr/>
+          <p:nvPr/>
+        </p:nvSpPr>
+        <p:spPr>
+          <a:xfrm>
+            <a:off x="6163056" y="3767328"/>
+            <a:ext cx="2651760" cy="64008"/>
+          </a:xfrm>
+          <a:prstGeom prst="rect">
+            <a:avLst/>
+          </a:prstGeom>
+          <a:solidFill>
+            <a:srgbClr val="46C8F0"/>
+          </a:solidFill>
+          <a:ln/>
+        </p:spPr>
+      </p:sp>
+      <p:sp>
+        <p:nvSpPr>
+          <p:cNvPr id="30" name="Text 28"/>
+          <p:cNvSpPr/>
+          <p:nvPr/>
+        </p:nvSpPr>
+        <p:spPr>
+          <a:xfrm>
+            <a:off x="6163056" y="3858768"/>
+            <a:ext cx="2651760" cy="274320"/>
+          </a:xfrm>
+          <a:prstGeom prst="rect">
+            <a:avLst/>
+          </a:prstGeom>
+          <a:noFill/>
+          <a:ln/>
+        </p:spPr>
+        <p:txBody>
+          <a:bodyPr wrap="square" lIns="0" tIns="0" rIns="0" bIns="0" rtlCol="0" anchor="ctr"/>
+          <a:lstStyle/>
+          <a:p>
+            <a:pPr indent="0" marL="0">
+              <a:buNone/>
+            </a:pPr>
+            <a:r>
+              <a:rPr lang="en-US" sz="1200" b="1" dirty="0">
+                <a:solidFill>
+                  <a:srgbClr val="000F46"/>
+                </a:solidFill>
+                <a:latin typeface="Source Sans 3" pitchFamily="34" charset="0"/>
+                <a:ea typeface="Source Sans 3" pitchFamily="34" charset="-122"/>
+                <a:cs typeface="Source Sans 3" pitchFamily="34" charset="-120"/>
+              </a:rPr>
+              <a:t>Course info</a:t>
+            </a:r>
+            <a:endParaRPr lang="en-US" sz="1200" dirty="0"/>
+          </a:p>
+        </p:txBody>
+      </p:sp>
+      <p:sp>
+        <p:nvSpPr>
+          <p:cNvPr id="31" name="Text 29"/>
+          <p:cNvSpPr/>
+          <p:nvPr/>
+        </p:nvSpPr>
+        <p:spPr>
+          <a:xfrm>
+            <a:off x="6163056" y="4169664"/>
+            <a:ext cx="2651760" cy="932688"/>
+          </a:xfrm>
+          <a:prstGeom prst="rect">
+            <a:avLst/>
+          </a:prstGeom>
+          <a:noFill/>
+          <a:ln/>
+        </p:spPr>
+        <p:txBody>
+          <a:bodyPr wrap="square" lIns="0" tIns="0" rIns="0" bIns="0" rtlCol="0" anchor="ctr"/>
+          <a:lstStyle/>
+          <a:p>
+            <a:pPr indent="0" marL="0">
+              <a:lnSpc>
+                <a:spcPct val="114000"/>
+              </a:lnSpc>
+              <a:buNone/>
+            </a:pPr>
+            <a:r>
+              <a:rPr lang="en-US" sz="1100" dirty="0">
+                <a:solidFill>
+                  <a:srgbClr val="5B5B6B"/>
+                </a:solidFill>
+                <a:latin typeface="Source Sans 3" pitchFamily="34" charset="0"/>
+                <a:ea typeface="Source Sans 3" pitchFamily="34" charset="-122"/>
+                <a:cs typeface="Source Sans 3" pitchFamily="34" charset="-120"/>
+              </a:rPr>
+              <a:t>Enrolled students follow 529 links back to the prospective site — for content missing from their own.</a:t>
+            </a:r>
+            <a:endParaRPr lang="en-US" sz="1100" dirty="0"/>
+          </a:p>
+        </p:txBody>
+      </p:sp>
+      <p:sp>
+        <p:nvSpPr>
+          <p:cNvPr id="32" name="Shape 30"/>
+          <p:cNvSpPr/>
+          <p:nvPr/>
+        </p:nvSpPr>
+        <p:spPr>
+          <a:xfrm>
+            <a:off x="8961120" y="3767328"/>
+            <a:ext cx="2651760" cy="64008"/>
+          </a:xfrm>
+          <a:prstGeom prst="rect">
+            <a:avLst/>
+          </a:prstGeom>
+          <a:solidFill>
+            <a:srgbClr val="46C8F0"/>
+          </a:solidFill>
+          <a:ln/>
+        </p:spPr>
+      </p:sp>
+      <p:sp>
+        <p:nvSpPr>
+          <p:cNvPr id="33" name="Text 31"/>
+          <p:cNvSpPr/>
+          <p:nvPr/>
+        </p:nvSpPr>
+        <p:spPr>
+          <a:xfrm>
+            <a:off x="8961120" y="3858768"/>
+            <a:ext cx="2651760" cy="274320"/>
+          </a:xfrm>
+          <a:prstGeom prst="rect">
+            <a:avLst/>
+          </a:prstGeom>
+          <a:noFill/>
+          <a:ln/>
+        </p:spPr>
+        <p:txBody>
+          <a:bodyPr wrap="square" lIns="0" tIns="0" rIns="0" bIns="0" rtlCol="0" anchor="ctr"/>
+          <a:lstStyle/>
+          <a:p>
+            <a:pPr indent="0" marL="0">
+              <a:buNone/>
+            </a:pPr>
+            <a:r>
+              <a:rPr lang="en-US" sz="1200" b="1" dirty="0">
+                <a:solidFill>
+                  <a:srgbClr val="000F46"/>
+                </a:solidFill>
+                <a:latin typeface="Source Sans 3" pitchFamily="34" charset="0"/>
+                <a:ea typeface="Source Sans 3" pitchFamily="34" charset="-122"/>
+                <a:cs typeface="Source Sans 3" pitchFamily="34" charset="-120"/>
+              </a:rPr>
+              <a:t>Alumni handoff</a:t>
+            </a:r>
+            <a:endParaRPr lang="en-US" sz="1200" dirty="0"/>
+          </a:p>
+        </p:txBody>
+      </p:sp>
+      <p:sp>
+        <p:nvSpPr>
+          <p:cNvPr id="34" name="Text 32"/>
+          <p:cNvSpPr/>
+          <p:nvPr/>
+        </p:nvSpPr>
+        <p:spPr>
+          <a:xfrm>
+            <a:off x="8961120" y="4169664"/>
+            <a:ext cx="2651760" cy="932688"/>
+          </a:xfrm>
+          <a:prstGeom prst="rect">
+            <a:avLst/>
+          </a:prstGeom>
+          <a:noFill/>
+          <a:ln/>
+        </p:spPr>
+        <p:txBody>
+          <a:bodyPr wrap="square" lIns="0" tIns="0" rIns="0" bIns="0" rtlCol="0" anchor="ctr"/>
+          <a:lstStyle/>
+          <a:p>
+            <a:pPr indent="0" marL="0">
+              <a:lnSpc>
+                <a:spcPct val="114000"/>
+              </a:lnSpc>
+              <a:buNone/>
+            </a:pPr>
+            <a:r>
+              <a:rPr lang="en-US" sz="1100" dirty="0">
+                <a:solidFill>
+                  <a:srgbClr val="5B5B6B"/>
+                </a:solidFill>
+                <a:latin typeface="Source Sans 3" pitchFamily="34" charset="0"/>
+                <a:ea typeface="Source Sans 3" pitchFamily="34" charset="-122"/>
+                <a:cs typeface="Source Sans 3" pitchFamily="34" charset="-120"/>
+              </a:rPr>
+              <a:t>0 current-student pages link forward to alumni, including graduation pages. No web path at exit.</a:t>
+            </a:r>
+            <a:endParaRPr lang="en-US" sz="1100" dirty="0"/>
+          </a:p>
+        </p:txBody>
+      </p:sp>
+      <p:sp>
+        <p:nvSpPr>
+          <p:cNvPr id="35" name="Text 33"/>
+          <p:cNvSpPr/>
+          <p:nvPr/>
+        </p:nvSpPr>
+        <p:spPr>
+          <a:xfrm>
+            <a:off x="566928" y="5266944"/>
+            <a:ext cx="10881360" cy="566928"/>
+          </a:xfrm>
+          <a:prstGeom prst="rect">
+            <a:avLst/>
+          </a:prstGeom>
+          <a:noFill/>
+          <a:ln/>
+        </p:spPr>
+        <p:txBody>
+          <a:bodyPr wrap="square" lIns="0" tIns="0" rIns="0" bIns="0" rtlCol="0" anchor="ctr"/>
+          <a:lstStyle/>
+          <a:p>
+            <a:pPr indent="0" marL="0">
+              <a:lnSpc>
+                <a:spcPct val="112000"/>
+              </a:lnSpc>
+              <a:buNone/>
+            </a:pPr>
+            <a:r>
+              <a:rPr lang="en-US" sz="1100" i="1" dirty="0">
+                <a:solidFill>
+                  <a:srgbClr val="000B34"/>
+                </a:solidFill>
+                <a:latin typeface="Source Sans 3" pitchFamily="34" charset="0"/>
+                <a:ea typeface="Source Sans 3" pitchFamily="34" charset="-122"/>
+                <a:cs typeface="Source Sans 3" pitchFamily="34" charset="-120"/>
+              </a:rPr>
+              <a:t>Current Students Website · Architecture, Building &amp; Planning · Arts · Business &amp; Economics · Education · Engineering &amp; IT · Fine Arts &amp; Music · Law · Medicine, Dentistry &amp; Health Sciences · Science · Melbourne Business School · Biomedical Sciences · Dental School · study.unimelb.edu.au · alumni.unimelb.edu.au</a:t>
+            </a:r>
+            <a:endParaRPr lang="en-US" sz="1100" dirty="0"/>
           </a:p>
         </p:txBody>
       </p:sp>
@@ -13021,8 +13596,8 @@
         </p:nvSpPr>
         <p:spPr>
           <a:xfrm>
-            <a:off x="6995160" y="1737360"/>
-            <a:ext cx="1691640" cy="347472"/>
+            <a:off x="6967728" y="1664208"/>
+            <a:ext cx="1737360" cy="530352"/>
           </a:xfrm>
           <a:prstGeom prst="rect">
             <a:avLst/>
@@ -13038,7 +13613,7 @@
               <a:buNone/>
             </a:pPr>
             <a:r>
-              <a:rPr lang="en-US" sz="1200" b="1" dirty="0">
+              <a:rPr lang="en-US" sz="1150" b="1" dirty="0">
                 <a:solidFill>
                   <a:srgbClr val="000F46"/>
                 </a:solidFill>
@@ -13046,9 +13621,26 @@
                 <a:ea typeface="Source Sans 3" pitchFamily="34" charset="-122"/>
                 <a:cs typeface="Source Sans 3" pitchFamily="34" charset="-120"/>
               </a:rPr>
-              <a:t>Central hub</a:t>
+              <a:t>Current Students</a:t>
             </a:r>
-            <a:endParaRPr lang="en-US" sz="1200" dirty="0"/>
+            <a:endParaRPr lang="en-US" sz="1150" dirty="0"/>
+          </a:p>
+          <a:p>
+            <a:pPr algn="ctr" indent="0" marL="0">
+              <a:buNone/>
+            </a:pPr>
+            <a:r>
+              <a:rPr lang="en-US" sz="1150" b="1" dirty="0">
+                <a:solidFill>
+                  <a:srgbClr val="000F46"/>
+                </a:solidFill>
+                <a:latin typeface="Source Sans 3" pitchFamily="34" charset="0"/>
+                <a:ea typeface="Source Sans 3" pitchFamily="34" charset="-122"/>
+                <a:cs typeface="Source Sans 3" pitchFamily="34" charset="-120"/>
+              </a:rPr>
+              <a:t>Website</a:t>
+            </a:r>
+            <a:endParaRPr lang="en-US" sz="1150" dirty="0"/>
           </a:p>
         </p:txBody>
       </p:sp>
@@ -13462,7 +14054,7 @@
                 <a:gridCol w="1828800"/>
                 <a:gridCol w="1645920"/>
               </a:tblGrid>
-              <a:tr h="457200">
+              <a:tr h="548640">
                 <a:tc>
                   <a:txBody>
                     <a:bodyPr/>
@@ -13548,7 +14140,28 @@
                           <a:ea typeface="Source Sans 3" pitchFamily="34" charset="-122"/>
                           <a:cs typeface="Source Sans 3" pitchFamily="34" charset="-120"/>
                         </a:rPr>
-                        <a:t>Central hub</a:t>
+                        <a:t>Current Students</a:t>
+                      </a:r>
+                      <a:endParaRPr lang="en-US" sz="1200" dirty="0">
+                        <a:latin typeface="Source Sans 3" charset="0"/>
+                        <a:ea typeface="Source Sans 3" charset="0"/>
+                        <a:cs typeface="Source Sans 3" charset="0"/>
+                      </a:endParaRPr>
+                    </a:p>
+                    <a:p>
+                      <a:pPr algn="l" indent="0" marL="0">
+                        <a:buNone/>
+                      </a:pPr>
+                      <a:r>
+                        <a:rPr lang="en-US" sz="1200" b="1" dirty="0">
+                          <a:solidFill>
+                            <a:srgbClr val="FFFFFF"/>
+                          </a:solidFill>
+                          <a:latin typeface="Source Sans 3" pitchFamily="34" charset="0"/>
+                          <a:ea typeface="Source Sans 3" pitchFamily="34" charset="-122"/>
+                          <a:cs typeface="Source Sans 3" pitchFamily="34" charset="-120"/>
+                        </a:rPr>
+                        <a:t>Website</a:t>
                       </a:r>
                       <a:endParaRPr lang="en-US" sz="1200" dirty="0">
                         <a:latin typeface="Source Sans 3" charset="0"/>
@@ -14300,7 +14913,7 @@
                           <a:ea typeface="Source Sans 3" pitchFamily="34" charset="-122"/>
                           <a:cs typeface="Source Sans 3" pitchFamily="34" charset="-120"/>
                         </a:rPr>
-                        <a:t>8 of 9</a:t>
+                        <a:t>8 of 9 (141 pp)</a:t>
                       </a:r>
                       <a:endParaRPr lang="en-US" sz="1150" dirty="0">
                         <a:latin typeface="Source Sans 3" charset="0"/>
@@ -15524,9 +16137,9 @@
                         <a:buNone/>
                       </a:pPr>
                       <a:r>
-                        <a:rPr lang="en-US" sz="1100" i="1" dirty="0">
+                        <a:rPr lang="en-US" sz="1150" dirty="0">
                           <a:solidFill>
-                            <a:srgbClr val="5B5B6B"/>
+                            <a:srgbClr val="1C1C28"/>
                           </a:solidFill>
                           <a:latin typeface="Source Sans 3" pitchFamily="34" charset="0"/>
                           <a:ea typeface="Source Sans 3" pitchFamily="34" charset="-122"/>
@@ -15534,7 +16147,7 @@
                         </a:rPr>
                         <a:t>Alumni engagement</a:t>
                       </a:r>
-                      <a:endParaRPr lang="en-US" sz="1100" dirty="0">
+                      <a:endParaRPr lang="en-US" sz="1150" dirty="0">
                         <a:latin typeface="Source Sans 3" charset="0"/>
                         <a:ea typeface="Source Sans 3" charset="0"/>
                         <a:cs typeface="Source Sans 3" charset="0"/>
@@ -15592,9 +16205,9 @@
                         <a:buNone/>
                       </a:pPr>
                       <a:r>
-                        <a:rPr lang="en-US" sz="1100" i="1" dirty="0">
+                        <a:rPr lang="en-US" sz="1150" dirty="0">
                           <a:solidFill>
-                            <a:srgbClr val="5B5B6B"/>
+                            <a:srgbClr val="1C1C28"/>
                           </a:solidFill>
                           <a:latin typeface="Source Sans 3" pitchFamily="34" charset="0"/>
                           <a:ea typeface="Source Sans 3" pitchFamily="34" charset="-122"/>
@@ -15602,7 +16215,7 @@
                         </a:rPr>
                         <a:t>—</a:t>
                       </a:r>
-                      <a:endParaRPr lang="en-US" sz="1100" dirty="0">
+                      <a:endParaRPr lang="en-US" sz="1150" dirty="0">
                         <a:latin typeface="Source Sans 3" charset="0"/>
                         <a:ea typeface="Source Sans 3" charset="0"/>
                         <a:cs typeface="Source Sans 3" charset="0"/>
@@ -15660,17 +16273,17 @@
                         <a:buNone/>
                       </a:pPr>
                       <a:r>
-                        <a:rPr lang="en-US" sz="1100" i="1" dirty="0">
+                        <a:rPr lang="en-US" sz="1150" dirty="0">
                           <a:solidFill>
-                            <a:srgbClr val="5B5B6B"/>
+                            <a:srgbClr val="1C1C28"/>
                           </a:solidFill>
                           <a:latin typeface="Source Sans 3" pitchFamily="34" charset="0"/>
                           <a:ea typeface="Source Sans 3" pitchFamily="34" charset="-122"/>
                           <a:cs typeface="Source Sans 3" pitchFamily="34" charset="-120"/>
                         </a:rPr>
-                        <a:t>Some faculties</a:t>
+                        <a:t>Some faculties (patchy)</a:t>
                       </a:r>
-                      <a:endParaRPr lang="en-US" sz="1100" dirty="0">
+                      <a:endParaRPr lang="en-US" sz="1150" dirty="0">
                         <a:latin typeface="Source Sans 3" charset="0"/>
                         <a:ea typeface="Source Sans 3" charset="0"/>
                         <a:cs typeface="Source Sans 3" charset="0"/>
@@ -15728,9 +16341,9 @@
                         <a:buNone/>
                       </a:pPr>
                       <a:r>
-                        <a:rPr lang="en-US" sz="1100" i="1" dirty="0">
+                        <a:rPr lang="en-US" sz="1150" dirty="0">
                           <a:solidFill>
-                            <a:srgbClr val="5B5B6B"/>
+                            <a:srgbClr val="1C1C28"/>
                           </a:solidFill>
                           <a:latin typeface="Source Sans 3" pitchFamily="34" charset="0"/>
                           <a:ea typeface="Source Sans 3" pitchFamily="34" charset="-122"/>
@@ -15738,7 +16351,7 @@
                         </a:rPr>
                         <a:t>MBS</a:t>
                       </a:r>
-                      <a:endParaRPr lang="en-US" sz="1100" dirty="0">
+                      <a:endParaRPr lang="en-US" sz="1150" dirty="0">
                         <a:latin typeface="Source Sans 3" charset="0"/>
                         <a:ea typeface="Source Sans 3" charset="0"/>
                         <a:cs typeface="Source Sans 3" charset="0"/>
@@ -15796,17 +16409,17 @@
                         <a:buNone/>
                       </a:pPr>
                       <a:r>
-                        <a:rPr lang="en-US" sz="1100" i="1" dirty="0">
+                        <a:rPr lang="en-US" sz="1150" dirty="0">
                           <a:solidFill>
-                            <a:srgbClr val="5B5B6B"/>
+                            <a:srgbClr val="1C1C28"/>
                           </a:solidFill>
                           <a:latin typeface="Source Sans 3" pitchFamily="34" charset="0"/>
                           <a:ea typeface="Source Sans 3" pitchFamily="34" charset="-122"/>
                           <a:cs typeface="Source Sans 3" pitchFamily="34" charset="-120"/>
                         </a:rPr>
-                        <a:t>No</a:t>
+                        <a:t>No — 0 links</a:t>
                       </a:r>
-                      <a:endParaRPr lang="en-US" sz="1100" dirty="0">
+                      <a:endParaRPr lang="en-US" sz="1150" dirty="0">
                         <a:latin typeface="Source Sans 3" charset="0"/>
                         <a:ea typeface="Source Sans 3" charset="0"/>
                         <a:cs typeface="Source Sans 3" charset="0"/>
@@ -15866,9 +16479,9 @@
                         <a:buNone/>
                       </a:pPr>
                       <a:r>
-                        <a:rPr lang="en-US" sz="1100" i="1" dirty="0">
+                        <a:rPr lang="en-US" sz="1150" dirty="0">
                           <a:solidFill>
-                            <a:srgbClr val="5B5B6B"/>
+                            <a:srgbClr val="1C1C28"/>
                           </a:solidFill>
                           <a:latin typeface="Source Sans 3" pitchFamily="34" charset="0"/>
                           <a:ea typeface="Source Sans 3" pitchFamily="34" charset="-122"/>
@@ -15876,7 +16489,7 @@
                         </a:rPr>
                         <a:t>study.unimelb</a:t>
                       </a:r>
-                      <a:endParaRPr lang="en-US" sz="1100" dirty="0">
+                      <a:endParaRPr lang="en-US" sz="1150" dirty="0">
                         <a:latin typeface="Source Sans 3" charset="0"/>
                         <a:ea typeface="Source Sans 3" charset="0"/>
                         <a:cs typeface="Source Sans 3" charset="0"/>
@@ -15934,9 +16547,9 @@
                         <a:buNone/>
                       </a:pPr>
                       <a:r>
-                        <a:rPr lang="en-US" sz="1100" i="1" dirty="0">
+                        <a:rPr lang="en-US" sz="1150" dirty="0">
                           <a:solidFill>
-                            <a:srgbClr val="5B5B6B"/>
+                            <a:srgbClr val="1C1C28"/>
                           </a:solidFill>
                           <a:latin typeface="Source Sans 3" pitchFamily="34" charset="0"/>
                           <a:ea typeface="Source Sans 3" pitchFamily="34" charset="-122"/>
@@ -15944,7 +16557,7 @@
                         </a:rPr>
                         <a:t>Entry paths</a:t>
                       </a:r>
-                      <a:endParaRPr lang="en-US" sz="1100" dirty="0">
+                      <a:endParaRPr lang="en-US" sz="1150" dirty="0">
                         <a:latin typeface="Source Sans 3" charset="0"/>
                         <a:ea typeface="Source Sans 3" charset="0"/>
                         <a:cs typeface="Source Sans 3" charset="0"/>
@@ -16002,17 +16615,17 @@
                         <a:buNone/>
                       </a:pPr>
                       <a:r>
-                        <a:rPr lang="en-US" sz="1100" i="1" dirty="0">
+                        <a:rPr lang="en-US" sz="1150" dirty="0">
                           <a:solidFill>
-                            <a:srgbClr val="5B5B6B"/>
+                            <a:srgbClr val="1C1C28"/>
                           </a:solidFill>
                           <a:latin typeface="Source Sans 3" pitchFamily="34" charset="0"/>
                           <a:ea typeface="Source Sans 3" pitchFamily="34" charset="-122"/>
                           <a:cs typeface="Source Sans 3" pitchFamily="34" charset="-120"/>
                         </a:rPr>
-                        <a:t>Some</a:t>
+                        <a:t>529 links back</a:t>
                       </a:r>
-                      <a:endParaRPr lang="en-US" sz="1100" dirty="0">
+                      <a:endParaRPr lang="en-US" sz="1150" dirty="0">
                         <a:latin typeface="Source Sans 3" charset="0"/>
                         <a:ea typeface="Source Sans 3" charset="0"/>
                         <a:cs typeface="Source Sans 3" charset="0"/>
@@ -16070,9 +16683,9 @@
                         <a:buNone/>
                       </a:pPr>
                       <a:r>
-                        <a:rPr lang="en-US" sz="1100" i="1" dirty="0">
+                        <a:rPr lang="en-US" sz="1150" dirty="0">
                           <a:solidFill>
-                            <a:srgbClr val="5B5B6B"/>
+                            <a:srgbClr val="1C1C28"/>
                           </a:solidFill>
                           <a:latin typeface="Source Sans 3" pitchFamily="34" charset="0"/>
                           <a:ea typeface="Source Sans 3" pitchFamily="34" charset="-122"/>
@@ -16080,7 +16693,7 @@
                         </a:rPr>
                         <a:t>—</a:t>
                       </a:r>
-                      <a:endParaRPr lang="en-US" sz="1100" dirty="0">
+                      <a:endParaRPr lang="en-US" sz="1150" dirty="0">
                         <a:latin typeface="Source Sans 3" charset="0"/>
                         <a:ea typeface="Source Sans 3" charset="0"/>
                         <a:cs typeface="Source Sans 3" charset="0"/>
@@ -16138,17 +16751,17 @@
                         <a:buNone/>
                       </a:pPr>
                       <a:r>
-                        <a:rPr lang="en-US" sz="1100" i="1" dirty="0">
+                        <a:rPr lang="en-US" sz="1150" dirty="0">
                           <a:solidFill>
-                            <a:srgbClr val="5B5B6B"/>
+                            <a:srgbClr val="1C1C28"/>
                           </a:solidFill>
                           <a:latin typeface="Source Sans 3" pitchFamily="34" charset="0"/>
                           <a:ea typeface="Source Sans 3" pitchFamily="34" charset="-122"/>
                           <a:cs typeface="Source Sans 3" pitchFamily="34" charset="-120"/>
                         </a:rPr>
-                        <a:t>Rarely</a:t>
+                        <a:t>One-way only</a:t>
                       </a:r>
-                      <a:endParaRPr lang="en-US" sz="1100" dirty="0">
+                      <a:endParaRPr lang="en-US" sz="1150" dirty="0">
                         <a:latin typeface="Source Sans 3" charset="0"/>
                         <a:ea typeface="Source Sans 3" charset="0"/>
                         <a:cs typeface="Source Sans 3" charset="0"/>
@@ -16204,52 +16817,13 @@
       </p:graphicFrame>
       <p:sp>
         <p:nvSpPr>
-          <p:cNvPr id="8" name="Text 5"/>
+          <p:cNvPr id="8" name="Shape 5"/>
           <p:cNvSpPr/>
           <p:nvPr/>
         </p:nvSpPr>
         <p:spPr>
           <a:xfrm>
-            <a:off x="566928" y="5596128"/>
-            <a:ext cx="6400800" cy="256032"/>
-          </a:xfrm>
-          <a:prstGeom prst="rect">
-            <a:avLst/>
-          </a:prstGeom>
-          <a:noFill/>
-          <a:ln/>
-        </p:spPr>
-        <p:txBody>
-          <a:bodyPr wrap="square" lIns="0" tIns="0" rIns="0" bIns="0" rtlCol="0" anchor="ctr"/>
-          <a:lstStyle/>
-          <a:p>
-            <a:pPr indent="0" marL="0">
-              <a:buNone/>
-            </a:pPr>
-            <a:r>
-              <a:rPr lang="en-US" sz="900" i="1" dirty="0">
-                <a:solidFill>
-                  <a:srgbClr val="5B5B6B"/>
-                </a:solidFill>
-                <a:latin typeface="Source Code Pro" pitchFamily="34" charset="0"/>
-                <a:ea typeface="Source Code Pro" pitchFamily="34" charset="-122"/>
-                <a:cs typeface="Source Code Pro" pitchFamily="34" charset="-120"/>
-              </a:rPr>
-              <a:t>Alumni and study.unimelb rows are indicative — full audit in progress.</a:t>
-            </a:r>
-            <a:endParaRPr lang="en-US" sz="900" dirty="0"/>
-          </a:p>
-        </p:txBody>
-      </p:sp>
-      <p:sp>
-        <p:nvSpPr>
-          <p:cNvPr id="9" name="Shape 6"/>
-          <p:cNvSpPr/>
-          <p:nvPr/>
-        </p:nvSpPr>
-        <p:spPr>
-          <a:xfrm>
-            <a:off x="566928" y="5897880"/>
+            <a:off x="566928" y="5623560"/>
             <a:ext cx="10881360" cy="621792"/>
           </a:xfrm>
           <a:prstGeom prst="rect">
@@ -16263,13 +16837,13 @@
       </p:sp>
       <p:sp>
         <p:nvSpPr>
-          <p:cNvPr id="10" name="Shape 7"/>
+          <p:cNvPr id="9" name="Shape 6"/>
           <p:cNvSpPr/>
           <p:nvPr/>
         </p:nvSpPr>
         <p:spPr>
           <a:xfrm>
-            <a:off x="566928" y="5897880"/>
+            <a:off x="566928" y="5623560"/>
             <a:ext cx="91440" cy="621792"/>
           </a:xfrm>
           <a:prstGeom prst="rect">
@@ -16283,13 +16857,13 @@
       </p:sp>
       <p:sp>
         <p:nvSpPr>
-          <p:cNvPr id="11" name="Text 8"/>
+          <p:cNvPr id="10" name="Text 7"/>
           <p:cNvSpPr/>
           <p:nvPr/>
         </p:nvSpPr>
         <p:spPr>
           <a:xfrm>
-            <a:off x="868680" y="5897880"/>
+            <a:off x="868680" y="5623560"/>
             <a:ext cx="10332720" cy="621792"/>
           </a:xfrm>
           <a:prstGeom prst="rect">
@@ -16542,7 +17116,7 @@
                 <a:ea typeface="Source Sans 3" pitchFamily="34" charset="-122"/>
                 <a:cs typeface="Source Sans 3" pitchFamily="34" charset="-120"/>
               </a:rPr>
-              <a:t>For each area — the same three questions:</a:t>
+              <a:t>For each finding — the same three questions:</a:t>
             </a:r>
             <a:endParaRPr lang="en-US" sz="1550" dirty="0"/>
           </a:p>
@@ -16710,7 +17284,7 @@
                 <a:ea typeface="Source Code Pro" pitchFamily="34" charset="-122"/>
                 <a:cs typeface="Source Code Pro" pitchFamily="34" charset="-120"/>
               </a:rPr>
-              <a:t>AREAS TO DISCUSS</a:t>
+              <a:t>WHAT THE DATA SHOWS</a:t>
             </a:r>
             <a:endParaRPr lang="en-US" sz="1100" dirty="0"/>
           </a:p>
@@ -16725,7 +17299,7 @@
         <p:spPr>
           <a:xfrm>
             <a:off x="7022592" y="1920240"/>
-            <a:ext cx="4389120" cy="512064"/>
+            <a:ext cx="4389120" cy="658368"/>
           </a:xfrm>
           <a:prstGeom prst="rect">
             <a:avLst/>
@@ -16750,7 +17324,7 @@
         <p:spPr>
           <a:xfrm>
             <a:off x="7150608" y="1920240"/>
-            <a:ext cx="4206240" cy="512064"/>
+            <a:ext cx="4206240" cy="658368"/>
           </a:xfrm>
           <a:prstGeom prst="rect">
             <a:avLst/>
@@ -16763,10 +17337,13 @@
           <a:lstStyle/>
           <a:p>
             <a:pPr indent="0" marL="0">
+              <a:lnSpc>
+                <a:spcPct val="110000"/>
+              </a:lnSpc>
               <a:buNone/>
             </a:pPr>
             <a:r>
-              <a:rPr lang="en-US" sz="1300" dirty="0">
+              <a:rPr lang="en-US" sz="1150" dirty="0">
                 <a:solidFill>
                   <a:srgbClr val="000B34"/>
                 </a:solidFill>
@@ -16774,9 +17351,9 @@
                 <a:ea typeface="Source Sans 3" pitchFamily="34" charset="-122"/>
                 <a:cs typeface="Source Sans 3" pitchFamily="34" charset="-120"/>
               </a:rPr>
-              <a:t>Course planning</a:t>
+              <a:t>Mentoring: 12 faculty alumni programs + matching student programs on all faculties. Neither side links to the other.</a:t>
             </a:r>
-            <a:endParaRPr lang="en-US" sz="1300" dirty="0"/>
+            <a:endParaRPr lang="en-US" sz="1150" dirty="0"/>
           </a:p>
         </p:txBody>
       </p:sp>
@@ -16788,8 +17365,8 @@
         </p:nvSpPr>
         <p:spPr>
           <a:xfrm>
-            <a:off x="7022592" y="2578608"/>
-            <a:ext cx="4389120" cy="512064"/>
+            <a:off x="7022592" y="2706624"/>
+            <a:ext cx="4389120" cy="658368"/>
           </a:xfrm>
           <a:prstGeom prst="rect">
             <a:avLst/>
@@ -16813,8 +17390,8 @@
         </p:nvSpPr>
         <p:spPr>
           <a:xfrm>
-            <a:off x="7150608" y="2578608"/>
-            <a:ext cx="4206240" cy="512064"/>
+            <a:off x="7150608" y="2706624"/>
+            <a:ext cx="4206240" cy="658368"/>
           </a:xfrm>
           <a:prstGeom prst="rect">
             <a:avLst/>
@@ -16827,10 +17404,13 @@
           <a:lstStyle/>
           <a:p>
             <a:pPr indent="0" marL="0">
+              <a:lnSpc>
+                <a:spcPct val="110000"/>
+              </a:lnSpc>
               <a:buNone/>
             </a:pPr>
             <a:r>
-              <a:rPr lang="en-US" sz="1300" dirty="0">
+              <a:rPr lang="en-US" sz="1150" dirty="0">
                 <a:solidFill>
                   <a:srgbClr val="000B34"/>
                 </a:solidFill>
@@ -16838,9 +17418,9 @@
                 <a:ea typeface="Source Sans 3" pitchFamily="34" charset="-122"/>
                 <a:cs typeface="Source Sans 3" pitchFamily="34" charset="-120"/>
               </a:rPr>
-              <a:t>Careers &amp; employability</a:t>
+              <a:t>Careers: 4 parallel presences — central, 8 faculties, study.unimelb, alumni. No cross-links in any direction.</a:t>
             </a:r>
-            <a:endParaRPr lang="en-US" sz="1300" dirty="0"/>
+            <a:endParaRPr lang="en-US" sz="1150" dirty="0"/>
           </a:p>
         </p:txBody>
       </p:sp>
@@ -16852,8 +17432,8 @@
         </p:nvSpPr>
         <p:spPr>
           <a:xfrm>
-            <a:off x="7022592" y="3236976"/>
-            <a:ext cx="4389120" cy="512064"/>
+            <a:off x="7022592" y="3493008"/>
+            <a:ext cx="4389120" cy="658368"/>
           </a:xfrm>
           <a:prstGeom prst="rect">
             <a:avLst/>
@@ -16877,8 +17457,8 @@
         </p:nvSpPr>
         <p:spPr>
           <a:xfrm>
-            <a:off x="7150608" y="3236976"/>
-            <a:ext cx="4206240" cy="512064"/>
+            <a:off x="7150608" y="3493008"/>
+            <a:ext cx="4206240" cy="658368"/>
           </a:xfrm>
           <a:prstGeom prst="rect">
             <a:avLst/>
@@ -16891,10 +17471,13 @@
           <a:lstStyle/>
           <a:p>
             <a:pPr indent="0" marL="0">
+              <a:lnSpc>
+                <a:spcPct val="110000"/>
+              </a:lnSpc>
               <a:buNone/>
             </a:pPr>
             <a:r>
-              <a:rPr lang="en-US" sz="1300" dirty="0">
+              <a:rPr lang="en-US" sz="1150" dirty="0">
                 <a:solidFill>
                   <a:srgbClr val="000B34"/>
                 </a:solidFill>
@@ -16902,9 +17485,9 @@
                 <a:ea typeface="Source Sans 3" pitchFamily="34" charset="-122"/>
                 <a:cs typeface="Source Sans 3" pitchFamily="34" charset="-120"/>
               </a:rPr>
-              <a:t>Faculty service requests</a:t>
+              <a:t>Graduation exit: 0 current-student pages link to alumni, including graduation pages. No web path forward.</a:t>
             </a:r>
-            <a:endParaRPr lang="en-US" sz="1300" dirty="0"/>
+            <a:endParaRPr lang="en-US" sz="1150" dirty="0"/>
           </a:p>
         </p:txBody>
       </p:sp>
@@ -16916,8 +17499,8 @@
         </p:nvSpPr>
         <p:spPr>
           <a:xfrm>
-            <a:off x="7022592" y="3895344"/>
-            <a:ext cx="4389120" cy="512064"/>
+            <a:off x="7022592" y="4279392"/>
+            <a:ext cx="4389120" cy="658368"/>
           </a:xfrm>
           <a:prstGeom prst="rect">
             <a:avLst/>
@@ -16941,8 +17524,8 @@
         </p:nvSpPr>
         <p:spPr>
           <a:xfrm>
-            <a:off x="7150608" y="3895344"/>
-            <a:ext cx="4206240" cy="512064"/>
+            <a:off x="7150608" y="4279392"/>
+            <a:ext cx="4206240" cy="658368"/>
           </a:xfrm>
           <a:prstGeom prst="rect">
             <a:avLst/>
@@ -16955,10 +17538,13 @@
           <a:lstStyle/>
           <a:p>
             <a:pPr indent="0" marL="0">
+              <a:lnSpc>
+                <a:spcPct val="110000"/>
+              </a:lnSpc>
               <a:buNone/>
             </a:pPr>
             <a:r>
-              <a:rPr lang="en-US" sz="1300" dirty="0">
+              <a:rPr lang="en-US" sz="1150" dirty="0">
                 <a:solidFill>
                   <a:srgbClr val="000B34"/>
                 </a:solidFill>
@@ -16966,9 +17552,9 @@
                 <a:ea typeface="Source Sans 3" pitchFamily="34" charset="-122"/>
                 <a:cs typeface="Source Sans 3" pitchFamily="34" charset="-120"/>
               </a:rPr>
-              <a:t>Further study pathways</a:t>
+              <a:t>529 enrolled-student links back to study.unimelb — for content that's missing from their own faculty sites.</a:t>
             </a:r>
-            <a:endParaRPr lang="en-US" sz="1300" dirty="0"/>
+            <a:endParaRPr lang="en-US" sz="1150" dirty="0"/>
           </a:p>
         </p:txBody>
       </p:sp>
@@ -16980,8 +17566,8 @@
         </p:nvSpPr>
         <p:spPr>
           <a:xfrm>
-            <a:off x="7022592" y="4553712"/>
-            <a:ext cx="4389120" cy="512064"/>
+            <a:off x="7022592" y="5065776"/>
+            <a:ext cx="4389120" cy="658368"/>
           </a:xfrm>
           <a:prstGeom prst="rect">
             <a:avLst/>
@@ -17005,8 +17591,8 @@
         </p:nvSpPr>
         <p:spPr>
           <a:xfrm>
-            <a:off x="7150608" y="4553712"/>
-            <a:ext cx="4206240" cy="512064"/>
+            <a:off x="7150608" y="5065776"/>
+            <a:ext cx="4206240" cy="658368"/>
           </a:xfrm>
           <a:prstGeom prst="rect">
             <a:avLst/>
@@ -17019,10 +17605,13 @@
           <a:lstStyle/>
           <a:p>
             <a:pPr indent="0" marL="0">
+              <a:lnSpc>
+                <a:spcPct val="110000"/>
+              </a:lnSpc>
               <a:buNone/>
             </a:pPr>
             <a:r>
-              <a:rPr lang="en-US" sz="1300" dirty="0">
+              <a:rPr lang="en-US" sz="1150" dirty="0">
                 <a:solidFill>
                   <a:srgbClr val="000B34"/>
                 </a:solidFill>
@@ -17030,73 +17619,9 @@
                 <a:ea typeface="Source Sans 3" pitchFamily="34" charset="-122"/>
                 <a:cs typeface="Source Sans 3" pitchFamily="34" charset="-120"/>
               </a:rPr>
-              <a:t>Alumni engagement</a:t>
+              <a:t>Scholarships: 3 presences (141 faculty, 75 study, 1 alumni) + 1 consolidation subdomain that none of them link to.</a:t>
             </a:r>
-            <a:endParaRPr lang="en-US" sz="1300" dirty="0"/>
-          </a:p>
-        </p:txBody>
-      </p:sp>
-      <p:sp>
-        <p:nvSpPr>
-          <p:cNvPr id="20" name="Shape 18"/>
-          <p:cNvSpPr/>
-          <p:nvPr/>
-        </p:nvSpPr>
-        <p:spPr>
-          <a:xfrm>
-            <a:off x="7022592" y="5212080"/>
-            <a:ext cx="4389120" cy="512064"/>
-          </a:xfrm>
-          <a:prstGeom prst="rect">
-            <a:avLst/>
-          </a:prstGeom>
-          <a:solidFill>
-            <a:srgbClr val="FFFFFF"/>
-          </a:solidFill>
-          <a:ln w="12700">
-            <a:solidFill>
-              <a:srgbClr val="DDDDE7"/>
-            </a:solidFill>
-            <a:prstDash val="solid"/>
-          </a:ln>
-        </p:spPr>
-      </p:sp>
-      <p:sp>
-        <p:nvSpPr>
-          <p:cNvPr id="21" name="Text 19"/>
-          <p:cNvSpPr/>
-          <p:nvPr/>
-        </p:nvSpPr>
-        <p:spPr>
-          <a:xfrm>
-            <a:off x="7150608" y="5212080"/>
-            <a:ext cx="4206240" cy="512064"/>
-          </a:xfrm>
-          <a:prstGeom prst="rect">
-            <a:avLst/>
-          </a:prstGeom>
-          <a:noFill/>
-          <a:ln/>
-        </p:spPr>
-        <p:txBody>
-          <a:bodyPr wrap="square" lIns="0" tIns="0" rIns="0" bIns="0" rtlCol="0" anchor="ctr"/>
-          <a:lstStyle/>
-          <a:p>
-            <a:pPr indent="0" marL="0">
-              <a:buNone/>
-            </a:pPr>
-            <a:r>
-              <a:rPr lang="en-US" sz="1300" dirty="0">
-                <a:solidFill>
-                  <a:srgbClr val="000B34"/>
-                </a:solidFill>
-                <a:latin typeface="Source Sans 3" pitchFamily="34" charset="0"/>
-                <a:ea typeface="Source Sans 3" pitchFamily="34" charset="-122"/>
-                <a:cs typeface="Source Sans 3" pitchFamily="34" charset="-120"/>
-              </a:rPr>
-              <a:t>study.unimelb.edu.au</a:t>
-            </a:r>
-            <a:endParaRPr lang="en-US" sz="1300" dirty="0"/>
+            <a:endParaRPr lang="en-US" sz="1150" dirty="0"/>
           </a:p>
         </p:txBody>
       </p:sp>

</xml_diff>

<commit_message>
fix(deck): correct hub page count to 74 from data/students-unimelb-ia.json
students.unimelb.edu.au is not auth-gated — the hub IA data exists in
data/students-unimelb-ia.json (74 pages across 4 sections). Remove the
incorrect "auth-gated" label and update all page counts:
- Slide 3 stat card 1: 4 → 74 pages (students.unimelb.edu.au)
- Slide 3 stat card 2: 1,169 → 1,150 pages (12 faculty/school sites)
- Slide 5 During Study box: removes auth-gated note, shows 74 pages
- Slide 5 faculty band: 1,169 → 1,150

Co-Authored-By: Claude Sonnet 4.6 <noreply@anthropic.com>
</commit_message>
<xml_diff>
--- a/discussion-deck/Current-Students-EndToEnd-Discussion.pptx
+++ b/discussion-deck/Current-Students-EndToEnd-Discussion.pptx
@@ -12259,7 +12259,7 @@
                 <a:ea typeface="Source Sans 3" pitchFamily="34" charset="-122"/>
                 <a:cs typeface="Source Sans 3" pitchFamily="34" charset="-120"/>
               </a:rPr>
-              <a:t>In June 2026, an automated browser visited every publicly reachable page — following links the same way a user would. Each page was read, classified and tagged by topic. The crawl covered the Current Students Website (students.unimelb.edu.au), 12 faculty &amp; school current-student sections, and both estate-adjacent sites. The hub is largely auth-gated — only 4 public pages were reachable.</a:t>
+              <a:t>In June 2026, an automated browser visited every publicly reachable page — following links the same way a user would. Each page was read, classified and tagged by topic. The crawl covered the Current Students Website (students.unimelb.edu.au), 12 faculty &amp; school current-student sections, and both estate-adjacent sites.</a:t>
             </a:r>
             <a:endParaRPr lang="en-US" sz="1350" dirty="0"/>
           </a:p>
@@ -12338,7 +12338,7 @@
                 <a:ea typeface="Fraunces" pitchFamily="34" charset="-122"/>
                 <a:cs typeface="Fraunces" pitchFamily="34" charset="-120"/>
               </a:rPr>
-              <a:t>4</a:t>
+              <a:t>74</a:t>
             </a:r>
             <a:endParaRPr lang="en-US" sz="4400" dirty="0"/>
           </a:p>
@@ -12400,7 +12400,7 @@
                 <a:ea typeface="Source Sans 3" pitchFamily="34" charset="-122"/>
                 <a:cs typeface="Source Sans 3" pitchFamily="34" charset="-120"/>
               </a:rPr>
-              <a:t>(auth-gated, 4 public pages)</a:t>
+              <a:t>Current Students Website</a:t>
             </a:r>
             <a:endParaRPr lang="en-US" sz="1150" dirty="0"/>
           </a:p>
@@ -12479,7 +12479,7 @@
                 <a:ea typeface="Fraunces" pitchFamily="34" charset="-122"/>
                 <a:cs typeface="Fraunces" pitchFamily="34" charset="-120"/>
               </a:rPr>
-              <a:t>1,169</a:t>
+              <a:t>1,150</a:t>
             </a:r>
             <a:endParaRPr lang="en-US" sz="4400" dirty="0"/>
           </a:p>
@@ -14028,7 +14028,7 @@
                 <a:ea typeface="Source Sans 3" pitchFamily="34" charset="-122"/>
                 <a:cs typeface="Source Sans 3" pitchFamily="34" charset="-120"/>
               </a:rPr>
-              <a:t>Faculty sites are unusual in this picture: they have a presence in all three phases — prospectus content for applicants, current-student sections (1,169 pages crawled), and alumni networks. The chips below show where the same content appears across phases without connecting.</a:t>
+              <a:t>Faculty sites are unusual in this picture: they have a presence in all three phases — prospectus content for applicants, current-student sections (1,150 pages crawled), and alumni networks. The chips below show where the same content appears across phases without connecting.</a:t>
             </a:r>
             <a:endParaRPr lang="en-US" sz="1550" dirty="0"/>
           </a:p>
@@ -14526,7 +14526,7 @@
               <a:buNone/>
             </a:pPr>
             <a:r>
-              <a:rPr lang="en-US" sz="750" dirty="0">
+              <a:rPr lang="en-US" sz="900" dirty="0">
                 <a:solidFill>
                   <a:srgbClr val="AAB0D4"/>
                 </a:solidFill>
@@ -14534,9 +14534,9 @@
                 <a:ea typeface="Source Code Pro" pitchFamily="34" charset="-122"/>
                 <a:cs typeface="Source Code Pro" pitchFamily="34" charset="-120"/>
               </a:rPr>
-              <a:t>(auth-gated, 4 public pages)</a:t>
+              <a:t>74 pages</a:t>
             </a:r>
-            <a:endParaRPr lang="en-US" sz="750" dirty="0"/>
+            <a:endParaRPr lang="en-US" sz="900" dirty="0"/>
           </a:p>
         </p:txBody>
       </p:sp>
@@ -14974,7 +14974,7 @@
                 <a:ea typeface="Source Sans 3" pitchFamily="34" charset="-122"/>
                 <a:cs typeface="Source Sans 3" pitchFamily="34" charset="-120"/>
               </a:rPr>
-              <a:t>1,169 current-student pages</a:t>
+              <a:t>1,150 current-student pages</a:t>
             </a:r>
             <a:endParaRPr lang="en-US" sz="1000" dirty="0"/>
           </a:p>

</xml_diff>

<commit_message>
feat(deck): add link flows + real faculty counts to slide 5
- Faculty band Before: replace "Prospectus & entry info" with "← 529 links sent back to study.unimelb (course plans & entry info)"
- Faculty band During: add "→ 4,629 links to hub" to the 1,150 CS pages label
- Faculty band After: replace "Alumni networks" with "13 faculty mentoring streams on alumni.unimelb / ✗ 0 links from faculty CS"
- Gap labels: fix "↔ 529 links" (misleading) to "→273 links" (study→hub) and "→ 0" to "✗ 0"
- Replace 4 overlap chips with 5-row LINK FLOWS section showing arrow direction, volume, and topic for each estate connection — 3 active (cyan), 2 broken (muted ✗)

Co-Authored-By: Claude Sonnet 4.6 <noreply@anthropic.com>
</commit_message>
<xml_diff>
--- a/discussion-deck/Current-Students-EndToEnd-Discussion.pptx
+++ b/discussion-deck/Current-Students-EndToEnd-Discussion.pptx
@@ -1129,7 +1129,7 @@
           <a:p>
             <a:r>
               <a:rPr lang="en-US" dirty="0"/>
-              <a:t>Walk through the diagram (~5 min). The key insight is the faculty band spanning all three phases — faculties are not just 'current student' sites, they have prospectus content and alumni sections too. The four overlap chips are today's discussion territory. Invite corrections to the picture before moving to open discussion. For each chip: 'is this a problem, and is anyone already working on it?'</a:t>
+              <a:t>Walk through the diagram (~5 min). The key insight is the faculty band spanning all three phases. Link flows (bottom section) show what the June 2026 crawl found: three active connections (faculty→hub 4,629 links; faculty→study 529 links; study→hub 273 links) and two completely broken connections (hub→alumni 0 links; faculty→alumni 0 links despite 13 mentoring streams existing on alumni.unimelb). The gap labels between core boxes show study→hub (273 links, active) and students→alumni (0 links, broken). Invite corrections to the picture — 'does this match what you see from your site's perspective?'</a:t>
             </a:r>
             <a:endParaRPr lang="en-US" dirty="0"/>
           </a:p>
@@ -14028,7 +14028,7 @@
                 <a:ea typeface="Source Sans 3" pitchFamily="34" charset="-122"/>
                 <a:cs typeface="Source Sans 3" pitchFamily="34" charset="-120"/>
               </a:rPr>
-              <a:t>Faculty sites are unusual in this picture: they have a presence in all three phases — prospectus content for applicants, current-student sections (1,150 pages crawled), and alumni networks. The chips below show where the same content appears across phases without connecting.</a:t>
+              <a:t>Faculty sites span all three phases — prospectus content for applicants, 1,150 current-student pages, and alumni networks. The link flows below show how estates connect and where the connections are broken. Arrows show direction and volume of links found in the June 2026 crawl.</a:t>
             </a:r>
             <a:endParaRPr lang="en-US" sz="1550" dirty="0"/>
           </a:p>
@@ -14696,13 +14696,13 @@
             <a:r>
               <a:rPr lang="en-US" sz="700" dirty="0">
                 <a:solidFill>
-                  <a:srgbClr val="000B34"/>
+                  <a:srgbClr val="2F95B7"/>
                 </a:solidFill>
                 <a:latin typeface="Source Code Pro" pitchFamily="34" charset="0"/>
                 <a:ea typeface="Source Code Pro" pitchFamily="34" charset="-122"/>
                 <a:cs typeface="Source Code Pro" pitchFamily="34" charset="-120"/>
               </a:rPr>
-              <a:t>↔ 529</a:t>
+              <a:t>→273</a:t>
             </a:r>
             <a:endParaRPr lang="en-US" sz="700" dirty="0"/>
           </a:p>
@@ -14716,7 +14716,7 @@
             <a:r>
               <a:rPr lang="en-US" sz="700" dirty="0">
                 <a:solidFill>
-                  <a:srgbClr val="000B34"/>
+                  <a:srgbClr val="2F95B7"/>
                 </a:solidFill>
                 <a:latin typeface="Source Code Pro" pitchFamily="34" charset="0"/>
                 <a:ea typeface="Source Code Pro" pitchFamily="34" charset="-122"/>
@@ -14764,7 +14764,7 @@
                 <a:ea typeface="Source Code Pro" pitchFamily="34" charset="-122"/>
                 <a:cs typeface="Source Code Pro" pitchFamily="34" charset="-120"/>
               </a:rPr>
-              <a:t>→ 0</a:t>
+              <a:t>✗ 0</a:t>
             </a:r>
             <a:endParaRPr lang="en-US" sz="700" dirty="0"/>
           </a:p>
@@ -14899,12 +14899,12 @@
           <a:p>
             <a:pPr algn="ctr" indent="0" marL="0">
               <a:lnSpc>
-                <a:spcPct val="110000"/>
+                <a:spcPct val="105000"/>
               </a:lnSpc>
               <a:buNone/>
             </a:pPr>
             <a:r>
-              <a:rPr lang="en-US" sz="1000" dirty="0">
+              <a:rPr lang="en-US" sz="900" dirty="0">
                 <a:solidFill>
                   <a:srgbClr val="000F46"/>
                 </a:solidFill>
@@ -14912,19 +14912,19 @@
                 <a:ea typeface="Source Sans 3" pitchFamily="34" charset="-122"/>
                 <a:cs typeface="Source Sans 3" pitchFamily="34" charset="-120"/>
               </a:rPr>
-              <a:t>Prospectus</a:t>
+              <a:t>← 529 links</a:t>
             </a:r>
-            <a:endParaRPr lang="en-US" sz="1000" dirty="0"/>
+            <a:endParaRPr lang="en-US" sz="900" dirty="0"/>
           </a:p>
           <a:p>
             <a:pPr algn="ctr" indent="0" marL="0">
               <a:lnSpc>
-                <a:spcPct val="110000"/>
+                <a:spcPct val="105000"/>
               </a:lnSpc>
               <a:buNone/>
             </a:pPr>
             <a:r>
-              <a:rPr lang="en-US" sz="1000" dirty="0">
+              <a:rPr lang="en-US" sz="900" dirty="0">
                 <a:solidFill>
                   <a:srgbClr val="000F46"/>
                 </a:solidFill>
@@ -14932,9 +14932,69 @@
                 <a:ea typeface="Source Sans 3" pitchFamily="34" charset="-122"/>
                 <a:cs typeface="Source Sans 3" pitchFamily="34" charset="-120"/>
               </a:rPr>
-              <a:t>&amp; entry info</a:t>
+              <a:t>sent back to</a:t>
             </a:r>
-            <a:endParaRPr lang="en-US" sz="1000" dirty="0"/>
+            <a:endParaRPr lang="en-US" sz="900" dirty="0"/>
+          </a:p>
+          <a:p>
+            <a:pPr algn="ctr" indent="0" marL="0">
+              <a:lnSpc>
+                <a:spcPct val="105000"/>
+              </a:lnSpc>
+              <a:buNone/>
+            </a:pPr>
+            <a:r>
+              <a:rPr lang="en-US" sz="900" dirty="0">
+                <a:solidFill>
+                  <a:srgbClr val="000F46"/>
+                </a:solidFill>
+                <a:latin typeface="Source Sans 3" pitchFamily="34" charset="0"/>
+                <a:ea typeface="Source Sans 3" pitchFamily="34" charset="-122"/>
+                <a:cs typeface="Source Sans 3" pitchFamily="34" charset="-120"/>
+              </a:rPr>
+              <a:t>study.unimelb</a:t>
+            </a:r>
+            <a:endParaRPr lang="en-US" sz="900" dirty="0"/>
+          </a:p>
+          <a:p>
+            <a:pPr algn="ctr" indent="0" marL="0">
+              <a:lnSpc>
+                <a:spcPct val="105000"/>
+              </a:lnSpc>
+              <a:buNone/>
+            </a:pPr>
+            <a:r>
+              <a:rPr lang="en-US" sz="900" dirty="0">
+                <a:solidFill>
+                  <a:srgbClr val="000F46"/>
+                </a:solidFill>
+                <a:latin typeface="Source Sans 3" pitchFamily="34" charset="0"/>
+                <a:ea typeface="Source Sans 3" pitchFamily="34" charset="-122"/>
+                <a:cs typeface="Source Sans 3" pitchFamily="34" charset="-120"/>
+              </a:rPr>
+              <a:t>(course plans</a:t>
+            </a:r>
+            <a:endParaRPr lang="en-US" sz="900" dirty="0"/>
+          </a:p>
+          <a:p>
+            <a:pPr algn="ctr" indent="0" marL="0">
+              <a:lnSpc>
+                <a:spcPct val="105000"/>
+              </a:lnSpc>
+              <a:buNone/>
+            </a:pPr>
+            <a:r>
+              <a:rPr lang="en-US" sz="900" dirty="0">
+                <a:solidFill>
+                  <a:srgbClr val="000F46"/>
+                </a:solidFill>
+                <a:latin typeface="Source Sans 3" pitchFamily="34" charset="0"/>
+                <a:ea typeface="Source Sans 3" pitchFamily="34" charset="-122"/>
+                <a:cs typeface="Source Sans 3" pitchFamily="34" charset="-120"/>
+              </a:rPr>
+              <a:t>&amp; entry info)</a:t>
+            </a:r>
+            <a:endParaRPr lang="en-US" sz="900" dirty="0"/>
           </a:p>
         </p:txBody>
       </p:sp>
@@ -14998,28 +15058,6 @@
             </a:r>
             <a:endParaRPr lang="en-US" sz="1000" dirty="0"/>
           </a:p>
-        </p:txBody>
-      </p:sp>
-      <p:sp>
-        <p:nvSpPr>
-          <p:cNvPr id="30" name="Text 28"/>
-          <p:cNvSpPr/>
-          <p:nvPr/>
-        </p:nvSpPr>
-        <p:spPr>
-          <a:xfrm>
-            <a:off x="10469880" y="3456432"/>
-            <a:ext cx="1143000" cy="914400"/>
-          </a:xfrm>
-          <a:prstGeom prst="rect">
-            <a:avLst/>
-          </a:prstGeom>
-          <a:noFill/>
-          <a:ln/>
-        </p:spPr>
-        <p:txBody>
-          <a:bodyPr wrap="square" lIns="0" tIns="0" rIns="0" bIns="0" rtlCol="0" anchor="ctr"/>
-          <a:lstStyle/>
           <a:p>
             <a:pPr algn="ctr" indent="0" marL="0">
               <a:lnSpc>
@@ -15036,19 +15074,41 @@
                 <a:ea typeface="Source Sans 3" pitchFamily="34" charset="-122"/>
                 <a:cs typeface="Source Sans 3" pitchFamily="34" charset="-120"/>
               </a:rPr>
-              <a:t>Alumni</a:t>
+              <a:t>→ 4,629 links to hub</a:t>
             </a:r>
             <a:endParaRPr lang="en-US" sz="1000" dirty="0"/>
           </a:p>
+        </p:txBody>
+      </p:sp>
+      <p:sp>
+        <p:nvSpPr>
+          <p:cNvPr id="30" name="Text 28"/>
+          <p:cNvSpPr/>
+          <p:nvPr/>
+        </p:nvSpPr>
+        <p:spPr>
+          <a:xfrm>
+            <a:off x="10469880" y="3456432"/>
+            <a:ext cx="1143000" cy="914400"/>
+          </a:xfrm>
+          <a:prstGeom prst="rect">
+            <a:avLst/>
+          </a:prstGeom>
+          <a:noFill/>
+          <a:ln/>
+        </p:spPr>
+        <p:txBody>
+          <a:bodyPr wrap="square" lIns="0" tIns="0" rIns="0" bIns="0" rtlCol="0" anchor="ctr"/>
+          <a:lstStyle/>
           <a:p>
             <a:pPr algn="ctr" indent="0" marL="0">
               <a:lnSpc>
-                <a:spcPct val="110000"/>
+                <a:spcPct val="105000"/>
               </a:lnSpc>
               <a:buNone/>
             </a:pPr>
             <a:r>
-              <a:rPr lang="en-US" sz="1000" dirty="0">
+              <a:rPr lang="en-US" sz="900" dirty="0">
                 <a:solidFill>
                   <a:srgbClr val="000F46"/>
                 </a:solidFill>
@@ -15056,9 +15116,89 @@
                 <a:ea typeface="Source Sans 3" pitchFamily="34" charset="-122"/>
                 <a:cs typeface="Source Sans 3" pitchFamily="34" charset="-120"/>
               </a:rPr>
-              <a:t>networks</a:t>
+              <a:t>13 faculty</a:t>
             </a:r>
-            <a:endParaRPr lang="en-US" sz="1000" dirty="0"/>
+            <a:endParaRPr lang="en-US" sz="900" dirty="0"/>
+          </a:p>
+          <a:p>
+            <a:pPr algn="ctr" indent="0" marL="0">
+              <a:lnSpc>
+                <a:spcPct val="105000"/>
+              </a:lnSpc>
+              <a:buNone/>
+            </a:pPr>
+            <a:r>
+              <a:rPr lang="en-US" sz="900" dirty="0">
+                <a:solidFill>
+                  <a:srgbClr val="000F46"/>
+                </a:solidFill>
+                <a:latin typeface="Source Sans 3" pitchFamily="34" charset="0"/>
+                <a:ea typeface="Source Sans 3" pitchFamily="34" charset="-122"/>
+                <a:cs typeface="Source Sans 3" pitchFamily="34" charset="-120"/>
+              </a:rPr>
+              <a:t>mentoring streams</a:t>
+            </a:r>
+            <a:endParaRPr lang="en-US" sz="900" dirty="0"/>
+          </a:p>
+          <a:p>
+            <a:pPr algn="ctr" indent="0" marL="0">
+              <a:lnSpc>
+                <a:spcPct val="105000"/>
+              </a:lnSpc>
+              <a:buNone/>
+            </a:pPr>
+            <a:r>
+              <a:rPr lang="en-US" sz="900" dirty="0">
+                <a:solidFill>
+                  <a:srgbClr val="000F46"/>
+                </a:solidFill>
+                <a:latin typeface="Source Sans 3" pitchFamily="34" charset="0"/>
+                <a:ea typeface="Source Sans 3" pitchFamily="34" charset="-122"/>
+                <a:cs typeface="Source Sans 3" pitchFamily="34" charset="-120"/>
+              </a:rPr>
+              <a:t>on alumni.unimelb</a:t>
+            </a:r>
+            <a:endParaRPr lang="en-US" sz="900" dirty="0"/>
+          </a:p>
+          <a:p>
+            <a:pPr algn="ctr" indent="0" marL="0">
+              <a:lnSpc>
+                <a:spcPct val="105000"/>
+              </a:lnSpc>
+              <a:buNone/>
+            </a:pPr>
+            <a:r>
+              <a:rPr lang="en-US" sz="900" dirty="0">
+                <a:solidFill>
+                  <a:srgbClr val="000F46"/>
+                </a:solidFill>
+                <a:latin typeface="Source Sans 3" pitchFamily="34" charset="0"/>
+                <a:ea typeface="Source Sans 3" pitchFamily="34" charset="-122"/>
+                <a:cs typeface="Source Sans 3" pitchFamily="34" charset="-120"/>
+              </a:rPr>
+              <a:t>✗ 0 links</a:t>
+            </a:r>
+            <a:endParaRPr lang="en-US" sz="900" dirty="0"/>
+          </a:p>
+          <a:p>
+            <a:pPr algn="ctr" indent="0" marL="0">
+              <a:lnSpc>
+                <a:spcPct val="105000"/>
+              </a:lnSpc>
+              <a:buNone/>
+            </a:pPr>
+            <a:r>
+              <a:rPr lang="en-US" sz="900" dirty="0">
+                <a:solidFill>
+                  <a:srgbClr val="000F46"/>
+                </a:solidFill>
+                <a:latin typeface="Source Sans 3" pitchFamily="34" charset="0"/>
+                <a:ea typeface="Source Sans 3" pitchFamily="34" charset="-122"/>
+                <a:cs typeface="Source Sans 3" pitchFamily="34" charset="-120"/>
+              </a:rPr>
+              <a:t>from faculty CS</a:t>
+            </a:r>
+            <a:endParaRPr lang="en-US" sz="900" dirty="0"/>
           </a:p>
         </p:txBody>
       </p:sp>
@@ -15071,7 +15211,7 @@
         <p:spPr>
           <a:xfrm>
             <a:off x="6720840" y="4462272"/>
-            <a:ext cx="4892040" cy="219456"/>
+            <a:ext cx="4892040" cy="201168"/>
           </a:xfrm>
           <a:prstGeom prst="rect">
             <a:avLst/>
@@ -15093,7 +15233,7 @@
         <p:spPr>
           <a:xfrm>
             <a:off x="6720840" y="4462272"/>
-            <a:ext cx="4892040" cy="219456"/>
+            <a:ext cx="4892040" cy="201168"/>
           </a:xfrm>
           <a:prstGeom prst="rect">
             <a:avLst/>
@@ -15117,7 +15257,7 @@
                 <a:ea typeface="Source Code Pro" pitchFamily="34" charset="-122"/>
                 <a:cs typeface="Source Code Pro" pitchFamily="34" charset="-120"/>
               </a:rPr>
-              <a:t>WHERE CONTENT OVERLAPS ACROSS PHASES</a:t>
+              <a:t>LINK FLOWS BETWEEN ESTATES</a:t>
             </a:r>
             <a:endParaRPr lang="en-US" sz="750" dirty="0"/>
           </a:p>
@@ -15131,8 +15271,8 @@
         </p:nvSpPr>
         <p:spPr>
           <a:xfrm>
-            <a:off x="6720840" y="4718304"/>
-            <a:ext cx="1188720" cy="685800"/>
+            <a:off x="6720840" y="4681728"/>
+            <a:ext cx="4892040" cy="164592"/>
           </a:xfrm>
           <a:prstGeom prst="rect">
             <a:avLst/>
@@ -15140,9 +15280,9 @@
           <a:solidFill>
             <a:srgbClr val="EAF6FB"/>
           </a:solidFill>
-          <a:ln w="9525">
+          <a:ln w="6350">
             <a:solidFill>
-              <a:srgbClr val="2F95B7"/>
+              <a:srgbClr val="DDDDE7"/>
             </a:solidFill>
             <a:prstDash val="solid"/>
           </a:ln>
@@ -15156,8 +15296,8 @@
         </p:nvSpPr>
         <p:spPr>
           <a:xfrm>
-            <a:off x="6720840" y="4745736"/>
-            <a:ext cx="1188720" cy="274320"/>
+            <a:off x="6766560" y="4681728"/>
+            <a:ext cx="2880360" cy="164592"/>
           </a:xfrm>
           <a:prstGeom prst="rect">
             <a:avLst/>
@@ -15169,21 +15309,21 @@
           <a:bodyPr wrap="square" lIns="0" tIns="0" rIns="0" bIns="0" rtlCol="0" anchor="ctr"/>
           <a:lstStyle/>
           <a:p>
-            <a:pPr algn="ctr" indent="0" marL="0">
+            <a:pPr indent="0" marL="0">
               <a:buNone/>
             </a:pPr>
             <a:r>
-              <a:rPr lang="en-US" sz="1050" b="1" dirty="0">
+              <a:rPr lang="en-US" sz="800" b="1" dirty="0">
                 <a:solidFill>
-                  <a:srgbClr val="000F46"/>
+                  <a:srgbClr val="2F95B7"/>
                 </a:solidFill>
-                <a:latin typeface="Source Sans 3" pitchFamily="34" charset="0"/>
-                <a:ea typeface="Source Sans 3" pitchFamily="34" charset="-122"/>
-                <a:cs typeface="Source Sans 3" pitchFamily="34" charset="-120"/>
+                <a:latin typeface="Source Code Pro" pitchFamily="34" charset="0"/>
+                <a:ea typeface="Source Code Pro" pitchFamily="34" charset="-122"/>
+                <a:cs typeface="Source Code Pro" pitchFamily="34" charset="-120"/>
               </a:rPr>
-              <a:t>Careers</a:t>
+              <a:t>→ Faculty CS → students.unimelb</a:t>
             </a:r>
-            <a:endParaRPr lang="en-US" sz="1050" dirty="0"/>
+            <a:endParaRPr lang="en-US" sz="800" dirty="0"/>
           </a:p>
         </p:txBody>
       </p:sp>
@@ -15195,8 +15335,8 @@
         </p:nvSpPr>
         <p:spPr>
           <a:xfrm>
-            <a:off x="6720840" y="5029200"/>
-            <a:ext cx="1188720" cy="347472"/>
+            <a:off x="9665208" y="4681728"/>
+            <a:ext cx="1901952" cy="164592"/>
           </a:xfrm>
           <a:prstGeom prst="rect">
             <a:avLst/>
@@ -15208,14 +15348,11 @@
           <a:bodyPr wrap="square" lIns="0" tIns="0" rIns="0" bIns="0" rtlCol="0" anchor="ctr"/>
           <a:lstStyle/>
           <a:p>
-            <a:pPr algn="ctr" indent="0" marL="0">
-              <a:lnSpc>
-                <a:spcPct val="105000"/>
-              </a:lnSpc>
+            <a:pPr indent="0" marL="0">
               <a:buNone/>
             </a:pPr>
             <a:r>
-              <a:rPr lang="en-US" sz="800" dirty="0">
+              <a:rPr lang="en-US" sz="750" dirty="0">
                 <a:solidFill>
                   <a:srgbClr val="5B5B6B"/>
                 </a:solidFill>
@@ -15223,7 +15360,71 @@
                 <a:ea typeface="Source Code Pro" pitchFamily="34" charset="-122"/>
                 <a:cs typeface="Source Code Pro" pitchFamily="34" charset="-120"/>
               </a:rPr>
-              <a:t>4 estates, none linked</a:t>
+              <a:t>4,629 links · all topics</a:t>
+            </a:r>
+            <a:endParaRPr lang="en-US" sz="750" dirty="0"/>
+          </a:p>
+        </p:txBody>
+      </p:sp>
+      <p:sp>
+        <p:nvSpPr>
+          <p:cNvPr id="36" name="Shape 34"/>
+          <p:cNvSpPr/>
+          <p:nvPr/>
+        </p:nvSpPr>
+        <p:spPr>
+          <a:xfrm>
+            <a:off x="6720840" y="4855464"/>
+            <a:ext cx="4892040" cy="164592"/>
+          </a:xfrm>
+          <a:prstGeom prst="rect">
+            <a:avLst/>
+          </a:prstGeom>
+          <a:solidFill>
+            <a:srgbClr val="EAF6FB"/>
+          </a:solidFill>
+          <a:ln w="6350">
+            <a:solidFill>
+              <a:srgbClr val="DDDDE7"/>
+            </a:solidFill>
+            <a:prstDash val="solid"/>
+          </a:ln>
+        </p:spPr>
+      </p:sp>
+      <p:sp>
+        <p:nvSpPr>
+          <p:cNvPr id="37" name="Text 35"/>
+          <p:cNvSpPr/>
+          <p:nvPr/>
+        </p:nvSpPr>
+        <p:spPr>
+          <a:xfrm>
+            <a:off x="6766560" y="4855464"/>
+            <a:ext cx="2880360" cy="164592"/>
+          </a:xfrm>
+          <a:prstGeom prst="rect">
+            <a:avLst/>
+          </a:prstGeom>
+          <a:noFill/>
+          <a:ln/>
+        </p:spPr>
+        <p:txBody>
+          <a:bodyPr wrap="square" lIns="0" tIns="0" rIns="0" bIns="0" rtlCol="0" anchor="ctr"/>
+          <a:lstStyle/>
+          <a:p>
+            <a:pPr indent="0" marL="0">
+              <a:buNone/>
+            </a:pPr>
+            <a:r>
+              <a:rPr lang="en-US" sz="800" b="1" dirty="0">
+                <a:solidFill>
+                  <a:srgbClr val="2F95B7"/>
+                </a:solidFill>
+                <a:latin typeface="Source Code Pro" pitchFamily="34" charset="0"/>
+                <a:ea typeface="Source Code Pro" pitchFamily="34" charset="-122"/>
+                <a:cs typeface="Source Code Pro" pitchFamily="34" charset="-120"/>
+              </a:rPr>
+              <a:t>→ Faculty CS → study.unimelb</a:t>
             </a:r>
             <a:endParaRPr lang="en-US" sz="800" dirty="0"/>
           </a:p>
@@ -15231,39 +15432,14 @@
       </p:sp>
       <p:sp>
         <p:nvSpPr>
-          <p:cNvPr id="36" name="Shape 34"/>
-          <p:cNvSpPr/>
-          <p:nvPr/>
-        </p:nvSpPr>
-        <p:spPr>
-          <a:xfrm>
-            <a:off x="7943850" y="4718304"/>
-            <a:ext cx="1188720" cy="685800"/>
-          </a:xfrm>
-          <a:prstGeom prst="rect">
-            <a:avLst/>
-          </a:prstGeom>
-          <a:solidFill>
-            <a:srgbClr val="EAF6FB"/>
-          </a:solidFill>
-          <a:ln w="9525">
-            <a:solidFill>
-              <a:srgbClr val="2F95B7"/>
-            </a:solidFill>
-            <a:prstDash val="solid"/>
-          </a:ln>
-        </p:spPr>
-      </p:sp>
-      <p:sp>
-        <p:nvSpPr>
-          <p:cNvPr id="37" name="Text 35"/>
-          <p:cNvSpPr/>
-          <p:nvPr/>
-        </p:nvSpPr>
-        <p:spPr>
-          <a:xfrm>
-            <a:off x="7943850" y="4745736"/>
-            <a:ext cx="1188720" cy="274320"/>
+          <p:cNvPr id="38" name="Text 36"/>
+          <p:cNvSpPr/>
+          <p:nvPr/>
+        </p:nvSpPr>
+        <p:spPr>
+          <a:xfrm>
+            <a:off x="9665208" y="4855464"/>
+            <a:ext cx="1901952" cy="164592"/>
           </a:xfrm>
           <a:prstGeom prst="rect">
             <a:avLst/>
@@ -15275,53 +15451,11 @@
           <a:bodyPr wrap="square" lIns="0" tIns="0" rIns="0" bIns="0" rtlCol="0" anchor="ctr"/>
           <a:lstStyle/>
           <a:p>
-            <a:pPr algn="ctr" indent="0" marL="0">
+            <a:pPr indent="0" marL="0">
               <a:buNone/>
             </a:pPr>
             <a:r>
-              <a:rPr lang="en-US" sz="1050" b="1" dirty="0">
-                <a:solidFill>
-                  <a:srgbClr val="000F46"/>
-                </a:solidFill>
-                <a:latin typeface="Source Sans 3" pitchFamily="34" charset="0"/>
-                <a:ea typeface="Source Sans 3" pitchFamily="34" charset="-122"/>
-                <a:cs typeface="Source Sans 3" pitchFamily="34" charset="-120"/>
-              </a:rPr>
-              <a:t>Mentoring</a:t>
-            </a:r>
-            <a:endParaRPr lang="en-US" sz="1050" dirty="0"/>
-          </a:p>
-        </p:txBody>
-      </p:sp>
-      <p:sp>
-        <p:nvSpPr>
-          <p:cNvPr id="38" name="Text 36"/>
-          <p:cNvSpPr/>
-          <p:nvPr/>
-        </p:nvSpPr>
-        <p:spPr>
-          <a:xfrm>
-            <a:off x="7943850" y="5029200"/>
-            <a:ext cx="1188720" cy="347472"/>
-          </a:xfrm>
-          <a:prstGeom prst="rect">
-            <a:avLst/>
-          </a:prstGeom>
-          <a:noFill/>
-          <a:ln/>
-        </p:spPr>
-        <p:txBody>
-          <a:bodyPr wrap="square" lIns="0" tIns="0" rIns="0" bIns="0" rtlCol="0" anchor="ctr"/>
-          <a:lstStyle/>
-          <a:p>
-            <a:pPr algn="ctr" indent="0" marL="0">
-              <a:lnSpc>
-                <a:spcPct val="105000"/>
-              </a:lnSpc>
-              <a:buNone/>
-            </a:pPr>
-            <a:r>
-              <a:rPr lang="en-US" sz="800" dirty="0">
+              <a:rPr lang="en-US" sz="750" dirty="0">
                 <a:solidFill>
                   <a:srgbClr val="5B5B6B"/>
                 </a:solidFill>
@@ -15329,7 +15463,71 @@
                 <a:ea typeface="Source Code Pro" pitchFamily="34" charset="-122"/>
                 <a:cs typeface="Source Code Pro" pitchFamily="34" charset="-120"/>
               </a:rPr>
-              <a:t>faculty ↔ alumni, no link</a:t>
+              <a:t>529 links · course planning</a:t>
+            </a:r>
+            <a:endParaRPr lang="en-US" sz="750" dirty="0"/>
+          </a:p>
+        </p:txBody>
+      </p:sp>
+      <p:sp>
+        <p:nvSpPr>
+          <p:cNvPr id="39" name="Shape 37"/>
+          <p:cNvSpPr/>
+          <p:nvPr/>
+        </p:nvSpPr>
+        <p:spPr>
+          <a:xfrm>
+            <a:off x="6720840" y="5029200"/>
+            <a:ext cx="4892040" cy="164592"/>
+          </a:xfrm>
+          <a:prstGeom prst="rect">
+            <a:avLst/>
+          </a:prstGeom>
+          <a:solidFill>
+            <a:srgbClr val="EAF6FB"/>
+          </a:solidFill>
+          <a:ln w="6350">
+            <a:solidFill>
+              <a:srgbClr val="DDDDE7"/>
+            </a:solidFill>
+            <a:prstDash val="solid"/>
+          </a:ln>
+        </p:spPr>
+      </p:sp>
+      <p:sp>
+        <p:nvSpPr>
+          <p:cNvPr id="40" name="Text 38"/>
+          <p:cNvSpPr/>
+          <p:nvPr/>
+        </p:nvSpPr>
+        <p:spPr>
+          <a:xfrm>
+            <a:off x="6766560" y="5029200"/>
+            <a:ext cx="2880360" cy="164592"/>
+          </a:xfrm>
+          <a:prstGeom prst="rect">
+            <a:avLst/>
+          </a:prstGeom>
+          <a:noFill/>
+          <a:ln/>
+        </p:spPr>
+        <p:txBody>
+          <a:bodyPr wrap="square" lIns="0" tIns="0" rIns="0" bIns="0" rtlCol="0" anchor="ctr"/>
+          <a:lstStyle/>
+          <a:p>
+            <a:pPr indent="0" marL="0">
+              <a:buNone/>
+            </a:pPr>
+            <a:r>
+              <a:rPr lang="en-US" sz="800" b="1" dirty="0">
+                <a:solidFill>
+                  <a:srgbClr val="2F95B7"/>
+                </a:solidFill>
+                <a:latin typeface="Source Code Pro" pitchFamily="34" charset="0"/>
+                <a:ea typeface="Source Code Pro" pitchFamily="34" charset="-122"/>
+                <a:cs typeface="Source Code Pro" pitchFamily="34" charset="-120"/>
+              </a:rPr>
+              <a:t>→ study.unimelb → students hub</a:t>
             </a:r>
             <a:endParaRPr lang="en-US" sz="800" dirty="0"/>
           </a:p>
@@ -15337,39 +15535,14 @@
       </p:sp>
       <p:sp>
         <p:nvSpPr>
-          <p:cNvPr id="39" name="Shape 37"/>
-          <p:cNvSpPr/>
-          <p:nvPr/>
-        </p:nvSpPr>
-        <p:spPr>
-          <a:xfrm>
-            <a:off x="9166860" y="4718304"/>
-            <a:ext cx="1188720" cy="685800"/>
-          </a:xfrm>
-          <a:prstGeom prst="rect">
-            <a:avLst/>
-          </a:prstGeom>
-          <a:solidFill>
-            <a:srgbClr val="EAF6FB"/>
-          </a:solidFill>
-          <a:ln w="9525">
-            <a:solidFill>
-              <a:srgbClr val="2F95B7"/>
-            </a:solidFill>
-            <a:prstDash val="solid"/>
-          </a:ln>
-        </p:spPr>
-      </p:sp>
-      <p:sp>
-        <p:nvSpPr>
-          <p:cNvPr id="40" name="Text 38"/>
-          <p:cNvSpPr/>
-          <p:nvPr/>
-        </p:nvSpPr>
-        <p:spPr>
-          <a:xfrm>
-            <a:off x="9166860" y="4745736"/>
-            <a:ext cx="1188720" cy="274320"/>
+          <p:cNvPr id="41" name="Text 39"/>
+          <p:cNvSpPr/>
+          <p:nvPr/>
+        </p:nvSpPr>
+        <p:spPr>
+          <a:xfrm>
+            <a:off x="9665208" y="5029200"/>
+            <a:ext cx="1901952" cy="164592"/>
           </a:xfrm>
           <a:prstGeom prst="rect">
             <a:avLst/>
@@ -15381,53 +15554,11 @@
           <a:bodyPr wrap="square" lIns="0" tIns="0" rIns="0" bIns="0" rtlCol="0" anchor="ctr"/>
           <a:lstStyle/>
           <a:p>
-            <a:pPr algn="ctr" indent="0" marL="0">
+            <a:pPr indent="0" marL="0">
               <a:buNone/>
             </a:pPr>
             <a:r>
-              <a:rPr lang="en-US" sz="1050" b="1" dirty="0">
-                <a:solidFill>
-                  <a:srgbClr val="000F46"/>
-                </a:solidFill>
-                <a:latin typeface="Source Sans 3" pitchFamily="34" charset="0"/>
-                <a:ea typeface="Source Sans 3" pitchFamily="34" charset="-122"/>
-                <a:cs typeface="Source Sans 3" pitchFamily="34" charset="-120"/>
-              </a:rPr>
-              <a:t>Course info</a:t>
-            </a:r>
-            <a:endParaRPr lang="en-US" sz="1050" dirty="0"/>
-          </a:p>
-        </p:txBody>
-      </p:sp>
-      <p:sp>
-        <p:nvSpPr>
-          <p:cNvPr id="41" name="Text 39"/>
-          <p:cNvSpPr/>
-          <p:nvPr/>
-        </p:nvSpPr>
-        <p:spPr>
-          <a:xfrm>
-            <a:off x="9166860" y="5029200"/>
-            <a:ext cx="1188720" cy="347472"/>
-          </a:xfrm>
-          <a:prstGeom prst="rect">
-            <a:avLst/>
-          </a:prstGeom>
-          <a:noFill/>
-          <a:ln/>
-        </p:spPr>
-        <p:txBody>
-          <a:bodyPr wrap="square" lIns="0" tIns="0" rIns="0" bIns="0" rtlCol="0" anchor="ctr"/>
-          <a:lstStyle/>
-          <a:p>
-            <a:pPr algn="ctr" indent="0" marL="0">
-              <a:lnSpc>
-                <a:spcPct val="105000"/>
-              </a:lnSpc>
-              <a:buNone/>
-            </a:pPr>
-            <a:r>
-              <a:rPr lang="en-US" sz="800" dirty="0">
+              <a:rPr lang="en-US" sz="750" dirty="0">
                 <a:solidFill>
                   <a:srgbClr val="5B5B6B"/>
                 </a:solidFill>
@@ -15435,9 +15566,9 @@
                 <a:ea typeface="Source Code Pro" pitchFamily="34" charset="-122"/>
                 <a:cs typeface="Source Code Pro" pitchFamily="34" charset="-120"/>
               </a:rPr>
-              <a:t>529 back-links, no forward path</a:t>
+              <a:t>273 links · course info</a:t>
             </a:r>
-            <a:endParaRPr lang="en-US" sz="800" dirty="0"/>
+            <a:endParaRPr lang="en-US" sz="750" dirty="0"/>
           </a:p>
         </p:txBody>
       </p:sp>
@@ -15449,18 +15580,18 @@
         </p:nvSpPr>
         <p:spPr>
           <a:xfrm>
-            <a:off x="10389870" y="4718304"/>
-            <a:ext cx="1188720" cy="685800"/>
+            <a:off x="6720840" y="5202936"/>
+            <a:ext cx="4892040" cy="164592"/>
           </a:xfrm>
           <a:prstGeom prst="rect">
             <a:avLst/>
           </a:prstGeom>
           <a:solidFill>
-            <a:srgbClr val="EAF6FB"/>
+            <a:srgbClr val="F4F4F4"/>
           </a:solidFill>
-          <a:ln w="9525">
+          <a:ln w="6350">
             <a:solidFill>
-              <a:srgbClr val="2F95B7"/>
+              <a:srgbClr val="DDDDE7"/>
             </a:solidFill>
             <a:prstDash val="solid"/>
           </a:ln>
@@ -15474,8 +15605,8 @@
         </p:nvSpPr>
         <p:spPr>
           <a:xfrm>
-            <a:off x="10389870" y="4745736"/>
-            <a:ext cx="1188720" cy="274320"/>
+            <a:off x="6766560" y="5202936"/>
+            <a:ext cx="2880360" cy="164592"/>
           </a:xfrm>
           <a:prstGeom prst="rect">
             <a:avLst/>
@@ -15487,53 +15618,11 @@
           <a:bodyPr wrap="square" lIns="0" tIns="0" rIns="0" bIns="0" rtlCol="0" anchor="ctr"/>
           <a:lstStyle/>
           <a:p>
-            <a:pPr algn="ctr" indent="0" marL="0">
+            <a:pPr indent="0" marL="0">
               <a:buNone/>
             </a:pPr>
             <a:r>
-              <a:rPr lang="en-US" sz="1050" b="1" dirty="0">
-                <a:solidFill>
-                  <a:srgbClr val="000F46"/>
-                </a:solidFill>
-                <a:latin typeface="Source Sans 3" pitchFamily="34" charset="0"/>
-                <a:ea typeface="Source Sans 3" pitchFamily="34" charset="-122"/>
-                <a:cs typeface="Source Sans 3" pitchFamily="34" charset="-120"/>
-              </a:rPr>
-              <a:t>Scholarships</a:t>
-            </a:r>
-            <a:endParaRPr lang="en-US" sz="1050" dirty="0"/>
-          </a:p>
-        </p:txBody>
-      </p:sp>
-      <p:sp>
-        <p:nvSpPr>
-          <p:cNvPr id="44" name="Text 42"/>
-          <p:cNvSpPr/>
-          <p:nvPr/>
-        </p:nvSpPr>
-        <p:spPr>
-          <a:xfrm>
-            <a:off x="10389870" y="5029200"/>
-            <a:ext cx="1188720" cy="347472"/>
-          </a:xfrm>
-          <a:prstGeom prst="rect">
-            <a:avLst/>
-          </a:prstGeom>
-          <a:noFill/>
-          <a:ln/>
-        </p:spPr>
-        <p:txBody>
-          <a:bodyPr wrap="square" lIns="0" tIns="0" rIns="0" bIns="0" rtlCol="0" anchor="ctr"/>
-          <a:lstStyle/>
-          <a:p>
-            <a:pPr algn="ctr" indent="0" marL="0">
-              <a:lnSpc>
-                <a:spcPct val="105000"/>
-              </a:lnSpc>
-              <a:buNone/>
-            </a:pPr>
-            <a:r>
-              <a:rPr lang="en-US" sz="800" dirty="0">
+              <a:rPr lang="en-US" sz="800" b="1" dirty="0">
                 <a:solidFill>
                   <a:srgbClr val="5B5B6B"/>
                 </a:solidFill>
@@ -15541,7 +15630,7 @@
                 <a:ea typeface="Source Code Pro" pitchFamily="34" charset="-122"/>
                 <a:cs typeface="Source Code Pro" pitchFamily="34" charset="-120"/>
               </a:rPr>
-              <a:t>3 presences, 1 unused entry point</a:t>
+              <a:t>✗ students hub → alumni.unimelb</a:t>
             </a:r>
             <a:endParaRPr lang="en-US" sz="800" dirty="0"/>
           </a:p>
@@ -15549,7 +15638,149 @@
       </p:sp>
       <p:sp>
         <p:nvSpPr>
+          <p:cNvPr id="44" name="Text 42"/>
+          <p:cNvSpPr/>
+          <p:nvPr/>
+        </p:nvSpPr>
+        <p:spPr>
+          <a:xfrm>
+            <a:off x="9665208" y="5202936"/>
+            <a:ext cx="1901952" cy="164592"/>
+          </a:xfrm>
+          <a:prstGeom prst="rect">
+            <a:avLst/>
+          </a:prstGeom>
+          <a:noFill/>
+          <a:ln/>
+        </p:spPr>
+        <p:txBody>
+          <a:bodyPr wrap="square" lIns="0" tIns="0" rIns="0" bIns="0" rtlCol="0" anchor="ctr"/>
+          <a:lstStyle/>
+          <a:p>
+            <a:pPr indent="0" marL="0">
+              <a:buNone/>
+            </a:pPr>
+            <a:r>
+              <a:rPr lang="en-US" sz="750" dirty="0">
+                <a:solidFill>
+                  <a:srgbClr val="5B5B6B"/>
+                </a:solidFill>
+                <a:latin typeface="Source Code Pro" pitchFamily="34" charset="0"/>
+                <a:ea typeface="Source Code Pro" pitchFamily="34" charset="-122"/>
+                <a:cs typeface="Source Code Pro" pitchFamily="34" charset="-120"/>
+              </a:rPr>
+              <a:t>0 links — graduation exit broken</a:t>
+            </a:r>
+            <a:endParaRPr lang="en-US" sz="750" dirty="0"/>
+          </a:p>
+        </p:txBody>
+      </p:sp>
+      <p:sp>
+        <p:nvSpPr>
           <p:cNvPr id="45" name="Shape 43"/>
+          <p:cNvSpPr/>
+          <p:nvPr/>
+        </p:nvSpPr>
+        <p:spPr>
+          <a:xfrm>
+            <a:off x="6720840" y="5376672"/>
+            <a:ext cx="4892040" cy="164592"/>
+          </a:xfrm>
+          <a:prstGeom prst="rect">
+            <a:avLst/>
+          </a:prstGeom>
+          <a:solidFill>
+            <a:srgbClr val="F4F4F4"/>
+          </a:solidFill>
+          <a:ln w="6350">
+            <a:solidFill>
+              <a:srgbClr val="DDDDE7"/>
+            </a:solidFill>
+            <a:prstDash val="solid"/>
+          </a:ln>
+        </p:spPr>
+      </p:sp>
+      <p:sp>
+        <p:nvSpPr>
+          <p:cNvPr id="46" name="Text 44"/>
+          <p:cNvSpPr/>
+          <p:nvPr/>
+        </p:nvSpPr>
+        <p:spPr>
+          <a:xfrm>
+            <a:off x="6766560" y="5376672"/>
+            <a:ext cx="2880360" cy="164592"/>
+          </a:xfrm>
+          <a:prstGeom prst="rect">
+            <a:avLst/>
+          </a:prstGeom>
+          <a:noFill/>
+          <a:ln/>
+        </p:spPr>
+        <p:txBody>
+          <a:bodyPr wrap="square" lIns="0" tIns="0" rIns="0" bIns="0" rtlCol="0" anchor="ctr"/>
+          <a:lstStyle/>
+          <a:p>
+            <a:pPr indent="0" marL="0">
+              <a:buNone/>
+            </a:pPr>
+            <a:r>
+              <a:rPr lang="en-US" sz="800" b="1" dirty="0">
+                <a:solidFill>
+                  <a:srgbClr val="5B5B6B"/>
+                </a:solidFill>
+                <a:latin typeface="Source Code Pro" pitchFamily="34" charset="0"/>
+                <a:ea typeface="Source Code Pro" pitchFamily="34" charset="-122"/>
+                <a:cs typeface="Source Code Pro" pitchFamily="34" charset="-120"/>
+              </a:rPr>
+              <a:t>✗ Faculty CS → alumni.unimelb</a:t>
+            </a:r>
+            <a:endParaRPr lang="en-US" sz="800" dirty="0"/>
+          </a:p>
+        </p:txBody>
+      </p:sp>
+      <p:sp>
+        <p:nvSpPr>
+          <p:cNvPr id="47" name="Text 45"/>
+          <p:cNvSpPr/>
+          <p:nvPr/>
+        </p:nvSpPr>
+        <p:spPr>
+          <a:xfrm>
+            <a:off x="9665208" y="5376672"/>
+            <a:ext cx="1901952" cy="164592"/>
+          </a:xfrm>
+          <a:prstGeom prst="rect">
+            <a:avLst/>
+          </a:prstGeom>
+          <a:noFill/>
+          <a:ln/>
+        </p:spPr>
+        <p:txBody>
+          <a:bodyPr wrap="square" lIns="0" tIns="0" rIns="0" bIns="0" rtlCol="0" anchor="ctr"/>
+          <a:lstStyle/>
+          <a:p>
+            <a:pPr indent="0" marL="0">
+              <a:buNone/>
+            </a:pPr>
+            <a:r>
+              <a:rPr lang="en-US" sz="750" dirty="0">
+                <a:solidFill>
+                  <a:srgbClr val="5B5B6B"/>
+                </a:solidFill>
+                <a:latin typeface="Source Code Pro" pitchFamily="34" charset="0"/>
+                <a:ea typeface="Source Code Pro" pitchFamily="34" charset="-122"/>
+                <a:cs typeface="Source Code Pro" pitchFamily="34" charset="-120"/>
+              </a:rPr>
+              <a:t>0 links — 13 mentoring streams not connected</a:t>
+            </a:r>
+            <a:endParaRPr lang="en-US" sz="750" dirty="0"/>
+          </a:p>
+        </p:txBody>
+      </p:sp>
+      <p:sp>
+        <p:nvSpPr>
+          <p:cNvPr id="48" name="Shape 46"/>
           <p:cNvSpPr/>
           <p:nvPr/>
         </p:nvSpPr>
@@ -15569,7 +15800,7 @@
       </p:sp>
       <p:sp>
         <p:nvSpPr>
-          <p:cNvPr id="46" name="Shape 44"/>
+          <p:cNvPr id="49" name="Shape 47"/>
           <p:cNvSpPr/>
           <p:nvPr/>
         </p:nvSpPr>
@@ -15589,7 +15820,7 @@
       </p:sp>
       <p:sp>
         <p:nvSpPr>
-          <p:cNvPr id="47" name="Text 45"/>
+          <p:cNvPr id="50" name="Text 48"/>
           <p:cNvSpPr/>
           <p:nvPr/>
         </p:nvSpPr>

</xml_diff>

<commit_message>
feat(deck): add current student topics slide (duplicate of overlap discussion)
New slide 6b — "Current student topics — where the content sits" — identical
structure to slide 6, with five crawl-backed findings focused on enrolled-
student journey topics:
  1. Course planning — hub planner vs 1,150 faculty CS pages, no link
  2. Placements & WIL — 207 faculty pages, hub has zero, no central entry
  3. Employability — 4 parallel presences (hub/8 faculties/study/alumni), 0 cross-links
  4. Student life — 3 community framings (hub/faculty/alumni), no connecting path
  5. Scholarships — 141 faculty pages, dedicated scholarships.unimelb not linked from CS

Co-Authored-By: Claude Sonnet 4.6 <noreply@anthropic.com>
</commit_message>
<xml_diff>
--- a/discussion-deck/Current-Students-EndToEnd-Discussion.pptx
+++ b/discussion-deck/Current-Students-EndToEnd-Discussion.pptx
@@ -17,9 +17,10 @@
     <p:sldId id="265" r:id="rId11"/>
     <p:sldId id="266" r:id="rId12"/>
     <p:sldId id="267" r:id="rId13"/>
+    <p:sldId id="268" r:id="rId14"/>
   </p:sldIdLst>
   <p:notesMasterIdLst>
-    <p:notesMasterId r:id="rId14"/>
+    <p:notesMasterId r:id="rId15"/>
   </p:notesMasterIdLst>
   <p:sldSz cx="12192000" cy="6858000"/>
   <p:notesSz cx="6858000" cy="12192000"/>
@@ -601,7 +602,7 @@
           <a:p>
             <a:r>
               <a:rPr lang="en-US" dirty="0"/>
-              <a:t>Backup. Pull up the next slide only if the room wants faculty-level specifics.</a:t>
+              <a:t>~3 min. Land next steps as questions, not conclusions. Confirm who picks up what from the capture board, and how we'll stay aligned (e.g. a follow-up). Thank the room.</a:t>
             </a:r>
             <a:endParaRPr lang="en-US" dirty="0"/>
           </a:p>
@@ -689,7 +690,7 @@
           <a:p>
             <a:r>
               <a:rPr lang="en-US" dirty="0"/>
-              <a:t>Reference only. Per-faculty page counts by topic, from the current-students crawl. Schools (*) run their own sites. Use to answer 'how much does faculty X have for topic Y?' Bigger numbers = more content there, not better or worse.</a:t>
+              <a:t>Backup. Pull up the next slide only if the room wants faculty-level specifics.</a:t>
             </a:r>
             <a:endParaRPr lang="en-US" dirty="0"/>
           </a:p>
@@ -777,7 +778,7 @@
           <a:p>
             <a:r>
               <a:rPr lang="en-US" dirty="0"/>
-              <a:t>Reference only — broader view of the estate across all four circles from the overlap diagram. All page counts are from the June 2026 crawl. See analysis/cross-site-overlap.md for full breakdown and verdicts.</a:t>
+              <a:t>Reference only. Per-faculty page counts by topic, from the current-students crawl. Schools (*) run their own sites. Use to answer 'how much does faculty X have for topic Y?' Bigger numbers = more content there, not better or worse.</a:t>
             </a:r>
             <a:endParaRPr lang="en-US" dirty="0"/>
           </a:p>
@@ -801,6 +802,94 @@
             <a:fld id="{F7021451-1387-4CA6-816F-3879F97B5CBC}" type="slidenum">
               <a:rPr lang="en-US"/>
               <a:t>12</a:t>
+            </a:fld>
+            <a:endParaRPr lang="en-US"/>
+          </a:p>
+        </p:txBody>
+      </p:sp>
+    </p:spTree>
+    <p:extLst>
+      <p:ext uri="{BB962C8B-B14F-4D97-AF65-F5344CB8AC3E}">
+        <p14:creationId xmlns:p14="http://schemas.microsoft.com/office/powerpoint/2010/main" val="1024086991"/>
+      </p:ext>
+    </p:extLst>
+  </p:cSld>
+  <p:clrMapOvr>
+    <a:masterClrMapping/>
+  </p:clrMapOvr>
+</p:notes>
+</file>
+
+<file path=ppt/notesSlides/notesSlide13.xml><?xml version="1.0" encoding="utf-8"?>
+<p:notes xmlns:a="http://schemas.openxmlformats.org/drawingml/2006/main" xmlns:r="http://schemas.openxmlformats.org/officeDocument/2006/relationships" xmlns:p="http://schemas.openxmlformats.org/presentationml/2006/main">
+  <p:cSld>
+    <p:spTree>
+      <p:nvGrpSpPr>
+        <p:cNvPr id="1" name=""/>
+        <p:cNvGrpSpPr/>
+        <p:nvPr/>
+      </p:nvGrpSpPr>
+      <p:grpSpPr>
+        <a:xfrm>
+          <a:off x="0" y="0"/>
+          <a:ext cx="0" cy="0"/>
+          <a:chOff x="0" y="0"/>
+          <a:chExt cx="0" cy="0"/>
+        </a:xfrm>
+      </p:grpSpPr>
+      <p:sp>
+        <p:nvSpPr>
+          <p:cNvPr id="2" name="Slide Image Placeholder 1"/>
+          <p:cNvSpPr>
+            <a:spLocks noGrp="1" noRot="1" noChangeAspect="1"/>
+          </p:cNvSpPr>
+          <p:nvPr>
+            <p:ph type="sldImg"/>
+          </p:nvPr>
+        </p:nvSpPr>
+        <p:spPr/>
+      </p:sp>
+      <p:sp>
+        <p:nvSpPr>
+          <p:cNvPr id="3" name="Notes Placeholder 2"/>
+          <p:cNvSpPr>
+            <a:spLocks noGrp="1"/>
+          </p:cNvSpPr>
+          <p:nvPr>
+            <p:ph type="body" idx="1"/>
+          </p:nvPr>
+        </p:nvSpPr>
+        <p:spPr/>
+        <p:txBody>
+          <a:bodyPr/>
+          <a:lstStyle/>
+          <a:p>
+            <a:r>
+              <a:rPr lang="en-US" dirty="0"/>
+              <a:t>Reference only — broader view of the estate across all four circles from the overlap diagram. All page counts are from the June 2026 crawl. See analysis/cross-site-overlap.md for full breakdown and verdicts.</a:t>
+            </a:r>
+            <a:endParaRPr lang="en-US" dirty="0"/>
+          </a:p>
+        </p:txBody>
+      </p:sp>
+      <p:sp>
+        <p:nvSpPr>
+          <p:cNvPr id="4" name="Slide Number Placeholder 3"/>
+          <p:cNvSpPr>
+            <a:spLocks noGrp="1"/>
+          </p:cNvSpPr>
+          <p:nvPr>
+            <p:ph type="sldNum" sz="quarter" idx="10"/>
+          </p:nvPr>
+        </p:nvSpPr>
+        <p:spPr/>
+        <p:txBody>
+          <a:bodyPr/>
+          <a:lstStyle/>
+          <a:p>
+            <a:fld id="{F7021451-1387-4CA6-816F-3879F97B5CBC}" type="slidenum">
+              <a:rPr lang="en-US"/>
+              <a:t>13</a:t>
             </a:fld>
             <a:endParaRPr lang="en-US"/>
           </a:p>
@@ -1305,7 +1394,7 @@
           <a:p>
             <a:r>
               <a:rPr lang="en-US" dirty="0"/>
-              <a:t>Ask: 'what's already underway in your area that touches these overlaps?' Pre-populate any known initiatives before the session. Goal: we don't want to invent solutions to problems someone else is already solving — connect first.</a:t>
+              <a:t>Use this slide for current student journey topics. Five data-backed findings from the June 2026 crawl across the current-student estate. For each: is this the right picture? Is the split intentional? Does it serve or confuse students? Keep out of solution mode — map the territory first.</a:t>
             </a:r>
             <a:endParaRPr lang="en-US" dirty="0"/>
           </a:p>
@@ -1393,7 +1482,7 @@
           <a:p>
             <a:r>
               <a:rPr lang="en-US" dirty="0"/>
-              <a:t>~5 min, capture mode. Fill the four columns from everything raised: overlaps people agreed on, work already in flight, things worth exploring, and a name against each. This is the artefact we take away.</a:t>
+              <a:t>Ask: 'what's already underway in your area that touches these overlaps?' Pre-populate any known initiatives before the session. Goal: we don't want to invent solutions to problems someone else is already solving — connect first.</a:t>
             </a:r>
             <a:endParaRPr lang="en-US" dirty="0"/>
           </a:p>
@@ -1481,7 +1570,7 @@
           <a:p>
             <a:r>
               <a:rPr lang="en-US" dirty="0"/>
-              <a:t>~3 min. Land next steps as questions, not conclusions. Confirm who picks up what from the capture board, and how we'll stay aligned (e.g. a follow-up). Thank the room.</a:t>
+              <a:t>~5 min, capture mode. Fill the four columns from everything raised: overlaps people agreed on, work already in flight, things worth exploring, and a name against each. This is the artefact we take away.</a:t>
             </a:r>
             <a:endParaRPr lang="en-US" dirty="0"/>
           </a:p>
@@ -2113,6 +2202,311 @@
     <p:bg>
       <p:bgPr>
         <a:solidFill>
+          <a:srgbClr val="000F46"/>
+        </a:solidFill>
+      </p:bgPr>
+    </p:bg>
+    <p:spTree>
+      <p:nvGrpSpPr>
+        <p:cNvPr id="1" name=""/>
+        <p:cNvGrpSpPr/>
+        <p:nvPr/>
+      </p:nvGrpSpPr>
+      <p:grpSpPr>
+        <a:xfrm>
+          <a:off x="0" y="0"/>
+          <a:ext cx="0" cy="0"/>
+          <a:chOff x="0" y="0"/>
+          <a:chExt cx="0" cy="0"/>
+        </a:xfrm>
+      </p:grpSpPr>
+      <p:sp>
+        <p:nvSpPr>
+          <p:cNvPr id="2" name="Shape 0"/>
+          <p:cNvSpPr/>
+          <p:nvPr/>
+        </p:nvSpPr>
+        <p:spPr>
+          <a:xfrm>
+            <a:off x="566928" y="658368"/>
+            <a:ext cx="274320" cy="274320"/>
+          </a:xfrm>
+          <a:prstGeom prst="rect">
+            <a:avLst/>
+          </a:prstGeom>
+          <a:solidFill>
+            <a:srgbClr val="46C8F0"/>
+          </a:solidFill>
+          <a:ln/>
+        </p:spPr>
+      </p:sp>
+      <p:sp>
+        <p:nvSpPr>
+          <p:cNvPr id="3" name="Text 1"/>
+          <p:cNvSpPr/>
+          <p:nvPr/>
+        </p:nvSpPr>
+        <p:spPr>
+          <a:xfrm>
+            <a:off x="969264" y="548640"/>
+            <a:ext cx="10058400" cy="640080"/>
+          </a:xfrm>
+          <a:prstGeom prst="rect">
+            <a:avLst/>
+          </a:prstGeom>
+          <a:noFill/>
+          <a:ln/>
+        </p:spPr>
+        <p:txBody>
+          <a:bodyPr wrap="square" lIns="0" tIns="0" rIns="0" bIns="0" rtlCol="0" anchor="ctr"/>
+          <a:lstStyle/>
+          <a:p>
+            <a:pPr indent="0" marL="0">
+              <a:buNone/>
+            </a:pPr>
+            <a:r>
+              <a:rPr lang="en-US" sz="3200" b="1" dirty="0">
+                <a:solidFill>
+                  <a:srgbClr val="FFFFFF"/>
+                </a:solidFill>
+                <a:latin typeface="Fraunces" pitchFamily="34" charset="0"/>
+                <a:ea typeface="Fraunces" pitchFamily="34" charset="-122"/>
+                <a:cs typeface="Fraunces" pitchFamily="34" charset="-120"/>
+              </a:rPr>
+              <a:t>Where to from here — together</a:t>
+            </a:r>
+            <a:endParaRPr lang="en-US" sz="3200" dirty="0"/>
+          </a:p>
+        </p:txBody>
+      </p:sp>
+      <p:sp>
+        <p:nvSpPr>
+          <p:cNvPr id="4" name="Text 2"/>
+          <p:cNvSpPr/>
+          <p:nvPr/>
+        </p:nvSpPr>
+        <p:spPr>
+          <a:xfrm>
+            <a:off x="585216" y="1508760"/>
+            <a:ext cx="10058400" cy="457200"/>
+          </a:xfrm>
+          <a:prstGeom prst="rect">
+            <a:avLst/>
+          </a:prstGeom>
+          <a:noFill/>
+          <a:ln/>
+        </p:spPr>
+        <p:txBody>
+          <a:bodyPr wrap="square" lIns="0" tIns="0" rIns="0" bIns="0" rtlCol="0" anchor="ctr"/>
+          <a:lstStyle/>
+          <a:p>
+            <a:pPr indent="0" marL="0">
+              <a:buNone/>
+            </a:pPr>
+            <a:r>
+              <a:rPr lang="en-US" sz="1700" i="1" dirty="0">
+                <a:solidFill>
+                  <a:srgbClr val="46C8F0"/>
+                </a:solidFill>
+                <a:latin typeface="Source Sans 3" pitchFamily="34" charset="0"/>
+                <a:ea typeface="Source Sans 3" pitchFamily="34" charset="-122"/>
+                <a:cs typeface="Source Sans 3" pitchFamily="34" charset="-120"/>
+              </a:rPr>
+              <a:t>Not conclusions — questions to take forward.</a:t>
+            </a:r>
+            <a:endParaRPr lang="en-US" sz="1700" dirty="0"/>
+          </a:p>
+        </p:txBody>
+      </p:sp>
+      <p:sp>
+        <p:nvSpPr>
+          <p:cNvPr id="5" name="Text 3"/>
+          <p:cNvSpPr/>
+          <p:nvPr/>
+        </p:nvSpPr>
+        <p:spPr>
+          <a:xfrm>
+            <a:off x="603504" y="2286000"/>
+            <a:ext cx="10424160" cy="3291840"/>
+          </a:xfrm>
+          <a:prstGeom prst="rect">
+            <a:avLst/>
+          </a:prstGeom>
+          <a:noFill/>
+          <a:ln/>
+        </p:spPr>
+        <p:txBody>
+          <a:bodyPr wrap="square" lIns="0" tIns="0" rIns="0" bIns="0" rtlCol="0" anchor="t"/>
+          <a:lstStyle/>
+          <a:p>
+            <a:pPr marL="228600" indent="-228600">
+              <a:spcAft>
+                <a:spcPts val="1600"/>
+              </a:spcAft>
+              <a:buSzPct val="100000"/>
+              <a:buChar char="•"/>
+            </a:pPr>
+            <a:r>
+              <a:rPr lang="en-US" sz="1800" dirty="0">
+                <a:solidFill>
+                  <a:srgbClr val="FFFFFF"/>
+                </a:solidFill>
+                <a:latin typeface="Source Sans 3" pitchFamily="34" charset="0"/>
+                <a:ea typeface="Source Sans 3" pitchFamily="34" charset="-122"/>
+                <a:cs typeface="Source Sans 3" pitchFamily="34" charset="-120"/>
+              </a:rPr>
+              <a:t>Across all areas: what did we agree are the real overlaps?</a:t>
+            </a:r>
+            <a:endParaRPr lang="en-US" sz="1800" dirty="0"/>
+          </a:p>
+          <a:p>
+            <a:pPr marL="228600" indent="-228600">
+              <a:spcAft>
+                <a:spcPts val="1600"/>
+              </a:spcAft>
+              <a:buSzPct val="100000"/>
+              <a:buChar char="•"/>
+            </a:pPr>
+            <a:r>
+              <a:rPr lang="en-US" sz="1800" dirty="0">
+                <a:solidFill>
+                  <a:srgbClr val="FFFFFF"/>
+                </a:solidFill>
+                <a:latin typeface="Source Sans 3" pitchFamily="34" charset="0"/>
+                <a:ea typeface="Source Sans 3" pitchFamily="34" charset="-122"/>
+                <a:cs typeface="Source Sans 3" pitchFamily="34" charset="-120"/>
+              </a:rPr>
+              <a:t>What is already in flight that we could connect or build on?</a:t>
+            </a:r>
+            <a:endParaRPr lang="en-US" sz="1800" dirty="0"/>
+          </a:p>
+          <a:p>
+            <a:pPr marL="228600" indent="-228600">
+              <a:spcAft>
+                <a:spcPts val="1600"/>
+              </a:spcAft>
+              <a:buSzPct val="100000"/>
+              <a:buChar char="•"/>
+            </a:pPr>
+            <a:r>
+              <a:rPr lang="en-US" sz="1800" dirty="0">
+                <a:solidFill>
+                  <a:srgbClr val="FFFFFF"/>
+                </a:solidFill>
+                <a:latin typeface="Source Sans 3" pitchFamily="34" charset="0"/>
+                <a:ea typeface="Source Sans 3" pitchFamily="34" charset="-122"/>
+                <a:cs typeface="Source Sans 3" pitchFamily="34" charset="-120"/>
+              </a:rPr>
+              <a:t>For the biggest overlap — what is one next step, and who is involved?</a:t>
+            </a:r>
+            <a:endParaRPr lang="en-US" sz="1800" dirty="0"/>
+          </a:p>
+          <a:p>
+            <a:pPr marL="228600" indent="-228600">
+              <a:spcAft>
+                <a:spcPts val="1600"/>
+              </a:spcAft>
+              <a:buSzPct val="100000"/>
+              <a:buChar char="•"/>
+            </a:pPr>
+            <a:r>
+              <a:rPr lang="en-US" sz="1800" dirty="0">
+                <a:solidFill>
+                  <a:srgbClr val="FFFFFF"/>
+                </a:solidFill>
+                <a:latin typeface="Source Sans 3" pitchFamily="34" charset="0"/>
+                <a:ea typeface="Source Sans 3" pitchFamily="34" charset="-122"/>
+                <a:cs typeface="Source Sans 3" pitchFamily="34" charset="-120"/>
+              </a:rPr>
+              <a:t>How will we keep aligned as this work continues?</a:t>
+            </a:r>
+            <a:endParaRPr lang="en-US" sz="1800" dirty="0"/>
+          </a:p>
+        </p:txBody>
+      </p:sp>
+      <p:pic>
+        <p:nvPicPr>
+          <p:cNvPr id="6" name="Image 0" descr="/Users/djmulholland/Documents/Claude/projects/unimelb-current-students-ia/discussion-deck/assets/logo-white.svg">    </p:cNvPr>
+          <p:cNvPicPr>
+            <a:picLocks noChangeAspect="1"/>
+          </p:cNvPicPr>
+          <p:nvPr/>
+        </p:nvPicPr>
+        <p:blipFill>
+          <a:blip r:embed="rId1">
+            <a:extLst>
+              <a:ext uri="{96DAC541-7B7A-43D3-8B79-37D633B846F1}">
+                <asvg:svgBlip xmlns:asvg="http://schemas.microsoft.com/office/drawing/2016/SVG/main" r:embed="rId2"/>
+              </a:ext>
+            </a:extLst>
+          </a:blip>
+          <a:stretch>
+            <a:fillRect/>
+          </a:stretch>
+        </p:blipFill>
+        <p:spPr>
+          <a:xfrm>
+            <a:off x="9601200" y="6053328"/>
+            <a:ext cx="2011680" cy="632143"/>
+          </a:xfrm>
+          <a:prstGeom prst="rect">
+            <a:avLst/>
+          </a:prstGeom>
+        </p:spPr>
+      </p:pic>
+      <p:sp>
+        <p:nvSpPr>
+          <p:cNvPr id="7" name="Text 4"/>
+          <p:cNvSpPr/>
+          <p:nvPr/>
+        </p:nvSpPr>
+        <p:spPr>
+          <a:xfrm>
+            <a:off x="603504" y="6217920"/>
+            <a:ext cx="5486400" cy="365760"/>
+          </a:xfrm>
+          <a:prstGeom prst="rect">
+            <a:avLst/>
+          </a:prstGeom>
+          <a:noFill/>
+          <a:ln/>
+        </p:spPr>
+        <p:txBody>
+          <a:bodyPr wrap="square" lIns="0" tIns="0" rIns="0" bIns="0" rtlCol="0" anchor="ctr"/>
+          <a:lstStyle/>
+          <a:p>
+            <a:pPr indent="0" marL="0">
+              <a:buNone/>
+            </a:pPr>
+            <a:r>
+              <a:rPr lang="en-US" sz="1200" dirty="0">
+                <a:solidFill>
+                  <a:srgbClr val="C9CDE6"/>
+                </a:solidFill>
+                <a:latin typeface="Source Code Pro" pitchFamily="34" charset="0"/>
+                <a:ea typeface="Source Code Pro" pitchFamily="34" charset="-122"/>
+                <a:cs typeface="Source Code Pro" pitchFamily="34" charset="-120"/>
+              </a:rPr>
+              <a:t>Thank you · discussion</a:t>
+            </a:r>
+            <a:endParaRPr lang="en-US" sz="1200" dirty="0"/>
+          </a:p>
+        </p:txBody>
+      </p:sp>
+    </p:spTree>
+  </p:cSld>
+  <p:clrMapOvr>
+    <a:masterClrMapping/>
+  </p:clrMapOvr>
+</p:sld>
+</file>
+
+<file path=ppt/slides/slide11.xml><?xml version="1.0" encoding="utf-8"?>
+<p:sld xmlns:a="http://schemas.openxmlformats.org/drawingml/2006/main" xmlns:r="http://schemas.openxmlformats.org/officeDocument/2006/relationships" xmlns:p="http://schemas.openxmlformats.org/presentationml/2006/main">
+  <p:cSld name="Slide 11">
+    <p:bg>
+      <p:bgPr>
+        <a:solidFill>
           <a:srgbClr val="000B34"/>
         </a:solidFill>
       </p:bgPr>
@@ -2237,9 +2631,9 @@
 </p:sld>
 </file>
 
-<file path=ppt/slides/slide11.xml><?xml version="1.0" encoding="utf-8"?>
+<file path=ppt/slides/slide12.xml><?xml version="1.0" encoding="utf-8"?>
 <p:sld xmlns:a="http://schemas.openxmlformats.org/drawingml/2006/main" xmlns:r="http://schemas.openxmlformats.org/officeDocument/2006/relationships" xmlns:p="http://schemas.openxmlformats.org/presentationml/2006/main">
-  <p:cSld name="Slide 11">
+  <p:cSld name="Slide 12">
     <p:bg>
       <p:bgPr>
         <a:solidFill>
@@ -2392,7 +2786,7 @@
                 <a:ea typeface="Source Sans 3" pitchFamily="34" charset="-122"/>
                 <a:cs typeface="Source Sans 3" pitchFamily="34" charset="-120"/>
               </a:rPr>
-              <a:t>11</a:t>
+              <a:t>12</a:t>
             </a:r>
             <a:endParaRPr lang="en-US" sz="900" dirty="0"/>
           </a:p>
@@ -2400,7 +2794,7 @@
       </p:sp>
       <p:graphicFrame>
         <p:nvGraphicFramePr>
-          <p:cNvPr id="12" name="Table 0"/>
+          <p:cNvPr id="13" name="Table 0"/>
           <p:cNvGraphicFramePr>
             <a:graphicFrameLocks noGrp="1"/>
           </p:cNvGraphicFramePr>
@@ -7893,9 +8287,9 @@
 </p:sld>
 </file>
 
-<file path=ppt/slides/slide12.xml><?xml version="1.0" encoding="utf-8"?>
+<file path=ppt/slides/slide13.xml><?xml version="1.0" encoding="utf-8"?>
 <p:sld xmlns:a="http://schemas.openxmlformats.org/drawingml/2006/main" xmlns:r="http://schemas.openxmlformats.org/officeDocument/2006/relationships" xmlns:p="http://schemas.openxmlformats.org/presentationml/2006/main">
-  <p:cSld name="Slide 12">
+  <p:cSld name="Slide 13">
     <p:bg>
       <p:bgPr>
         <a:solidFill>
@@ -8048,7 +8442,7 @@
                 <a:ea typeface="Source Sans 3" pitchFamily="34" charset="-122"/>
                 <a:cs typeface="Source Sans 3" pitchFamily="34" charset="-120"/>
               </a:rPr>
-              <a:t>12</a:t>
+              <a:t>13</a:t>
             </a:r>
             <a:endParaRPr lang="en-US" sz="900" dirty="0"/>
           </a:p>
@@ -8098,7 +8492,7 @@
       </p:sp>
       <p:graphicFrame>
         <p:nvGraphicFramePr>
-          <p:cNvPr id="13" name="Table 0"/>
+          <p:cNvPr id="14" name="Table 0"/>
           <p:cNvGraphicFramePr>
             <a:graphicFrameLocks noGrp="1"/>
           </p:cNvGraphicFramePr>
@@ -16673,7 +17067,7 @@
                 <a:ea typeface="Fraunces" pitchFamily="34" charset="-122"/>
                 <a:cs typeface="Fraunces" pitchFamily="34" charset="-120"/>
               </a:rPr>
-              <a:t>What's already in flight</a:t>
+              <a:t>Current student topics — where the content sits</a:t>
             </a:r>
             <a:endParaRPr lang="en-US" sz="2900" dirty="0"/>
           </a:p>
@@ -16766,6 +17160,723 @@
         <p:spPr>
           <a:xfrm>
             <a:off x="566928" y="1325880"/>
+            <a:ext cx="5760720" cy="4389120"/>
+          </a:xfrm>
+          <a:prstGeom prst="rect">
+            <a:avLst/>
+          </a:prstGeom>
+          <a:noFill/>
+          <a:ln/>
+        </p:spPr>
+        <p:txBody>
+          <a:bodyPr wrap="square" lIns="0" tIns="0" rIns="0" bIns="0" rtlCol="0" anchor="t"/>
+          <a:lstStyle/>
+          <a:p>
+            <a:pPr indent="0" marL="0">
+              <a:lnSpc>
+                <a:spcPct val="122000"/>
+              </a:lnSpc>
+              <a:spcAft>
+                <a:spcPts val="1600"/>
+              </a:spcAft>
+              <a:buNone/>
+            </a:pPr>
+            <a:r>
+              <a:rPr lang="en-US" sz="1550" b="1" dirty="0">
+                <a:solidFill>
+                  <a:srgbClr val="1C1C28"/>
+                </a:solidFill>
+                <a:latin typeface="Source Sans 3" pitchFamily="34" charset="0"/>
+                <a:ea typeface="Source Sans 3" pitchFamily="34" charset="-122"/>
+                <a:cs typeface="Source Sans 3" pitchFamily="34" charset="-120"/>
+              </a:rPr>
+              <a:t>For each topic area — the same three questions:</a:t>
+            </a:r>
+            <a:endParaRPr lang="en-US" sz="1550" dirty="0"/>
+          </a:p>
+          <a:p>
+            <a:pPr indent="0" marL="0">
+              <a:lnSpc>
+                <a:spcPct val="122000"/>
+              </a:lnSpc>
+              <a:spcAft>
+                <a:spcPts val="1000"/>
+              </a:spcAft>
+              <a:buNone/>
+            </a:pPr>
+            <a:r>
+              <a:rPr lang="en-US" sz="1550" dirty="0">
+                <a:solidFill>
+                  <a:srgbClr val="1C1C28"/>
+                </a:solidFill>
+                <a:latin typeface="Source Sans 3" pitchFamily="34" charset="0"/>
+                <a:ea typeface="Source Sans 3" pitchFamily="34" charset="-122"/>
+                <a:cs typeface="Source Sans 3" pitchFamily="34" charset="-120"/>
+              </a:rPr>
+              <a:t>1.  Is the overlap intentional, or accidental?</a:t>
+            </a:r>
+            <a:endParaRPr lang="en-US" sz="1550" dirty="0"/>
+          </a:p>
+          <a:p>
+            <a:pPr indent="0" marL="0">
+              <a:lnSpc>
+                <a:spcPct val="122000"/>
+              </a:lnSpc>
+              <a:spcAft>
+                <a:spcPts val="1000"/>
+              </a:spcAft>
+              <a:buNone/>
+            </a:pPr>
+            <a:r>
+              <a:rPr lang="en-US" sz="1550" dirty="0">
+                <a:solidFill>
+                  <a:srgbClr val="1C1C28"/>
+                </a:solidFill>
+                <a:latin typeface="Source Sans 3" pitchFamily="34" charset="0"/>
+                <a:ea typeface="Source Sans 3" pitchFamily="34" charset="-122"/>
+                <a:cs typeface="Source Sans 3" pitchFamily="34" charset="-120"/>
+              </a:rPr>
+              <a:t>2.  Does it help or hinder the student?</a:t>
+            </a:r>
+            <a:endParaRPr lang="en-US" sz="1550" dirty="0"/>
+          </a:p>
+          <a:p>
+            <a:pPr indent="0" marL="0">
+              <a:lnSpc>
+                <a:spcPct val="122000"/>
+              </a:lnSpc>
+              <a:spcAft>
+                <a:spcPts val="2800"/>
+              </a:spcAft>
+              <a:buNone/>
+            </a:pPr>
+            <a:r>
+              <a:rPr lang="en-US" sz="1550" dirty="0">
+                <a:solidFill>
+                  <a:srgbClr val="1C1C28"/>
+                </a:solidFill>
+                <a:latin typeface="Source Sans 3" pitchFamily="34" charset="0"/>
+                <a:ea typeface="Source Sans 3" pitchFamily="34" charset="-122"/>
+                <a:cs typeface="Source Sans 3" pitchFamily="34" charset="-120"/>
+              </a:rPr>
+              <a:t>3.  Is someone already working on it?</a:t>
+            </a:r>
+            <a:endParaRPr lang="en-US" sz="1550" dirty="0"/>
+          </a:p>
+          <a:p>
+            <a:pPr indent="0" marL="0">
+              <a:lnSpc>
+                <a:spcPct val="122000"/>
+              </a:lnSpc>
+              <a:buNone/>
+            </a:pPr>
+            <a:r>
+              <a:rPr lang="en-US" sz="1550" dirty="0">
+                <a:solidFill>
+                  <a:srgbClr val="5B5B6B"/>
+                </a:solidFill>
+                <a:latin typeface="Source Sans 3" pitchFamily="34" charset="0"/>
+                <a:ea typeface="Source Sans 3" pitchFamily="34" charset="-122"/>
+                <a:cs typeface="Source Sans 3" pitchFamily="34" charset="-120"/>
+              </a:rPr>
+              <a:t>Use the capture board to note what we agree on, what's already in flight, what's worth exploring, and who's involved.</a:t>
+            </a:r>
+            <a:endParaRPr lang="en-US" sz="1550" dirty="0"/>
+          </a:p>
+        </p:txBody>
+      </p:sp>
+      <p:sp>
+        <p:nvSpPr>
+          <p:cNvPr id="7" name="Shape 5"/>
+          <p:cNvSpPr/>
+          <p:nvPr/>
+        </p:nvSpPr>
+        <p:spPr>
+          <a:xfrm>
+            <a:off x="6720840" y="1280160"/>
+            <a:ext cx="4910328" cy="4846320"/>
+          </a:xfrm>
+          <a:prstGeom prst="rect">
+            <a:avLst/>
+          </a:prstGeom>
+          <a:solidFill>
+            <a:srgbClr val="EAF6FB"/>
+          </a:solidFill>
+          <a:ln/>
+        </p:spPr>
+      </p:sp>
+      <p:sp>
+        <p:nvSpPr>
+          <p:cNvPr id="8" name="Shape 6"/>
+          <p:cNvSpPr/>
+          <p:nvPr/>
+        </p:nvSpPr>
+        <p:spPr>
+          <a:xfrm>
+            <a:off x="6720840" y="1280160"/>
+            <a:ext cx="91440" cy="4846320"/>
+          </a:xfrm>
+          <a:prstGeom prst="rect">
+            <a:avLst/>
+          </a:prstGeom>
+          <a:solidFill>
+            <a:srgbClr val="46C8F0"/>
+          </a:solidFill>
+          <a:ln/>
+        </p:spPr>
+      </p:sp>
+      <p:sp>
+        <p:nvSpPr>
+          <p:cNvPr id="9" name="Text 7"/>
+          <p:cNvSpPr/>
+          <p:nvPr/>
+        </p:nvSpPr>
+        <p:spPr>
+          <a:xfrm>
+            <a:off x="7022592" y="1481328"/>
+            <a:ext cx="4480560" cy="274320"/>
+          </a:xfrm>
+          <a:prstGeom prst="rect">
+            <a:avLst/>
+          </a:prstGeom>
+          <a:noFill/>
+          <a:ln/>
+        </p:spPr>
+        <p:txBody>
+          <a:bodyPr wrap="square" lIns="0" tIns="0" rIns="0" bIns="0" rtlCol="0" anchor="ctr"/>
+          <a:lstStyle/>
+          <a:p>
+            <a:pPr indent="0" marL="0">
+              <a:buNone/>
+            </a:pPr>
+            <a:r>
+              <a:rPr lang="en-US" sz="1100" b="1" spc="200" kern="0" dirty="0">
+                <a:solidFill>
+                  <a:srgbClr val="2F95B7"/>
+                </a:solidFill>
+                <a:latin typeface="Source Code Pro" pitchFamily="34" charset="0"/>
+                <a:ea typeface="Source Code Pro" pitchFamily="34" charset="-122"/>
+                <a:cs typeface="Source Code Pro" pitchFamily="34" charset="-120"/>
+              </a:rPr>
+              <a:t>WHAT THE DATA SHOWS</a:t>
+            </a:r>
+            <a:endParaRPr lang="en-US" sz="1100" dirty="0"/>
+          </a:p>
+        </p:txBody>
+      </p:sp>
+      <p:sp>
+        <p:nvSpPr>
+          <p:cNvPr id="10" name="Shape 8"/>
+          <p:cNvSpPr/>
+          <p:nvPr/>
+        </p:nvSpPr>
+        <p:spPr>
+          <a:xfrm>
+            <a:off x="7022592" y="1920240"/>
+            <a:ext cx="4389120" cy="731520"/>
+          </a:xfrm>
+          <a:prstGeom prst="rect">
+            <a:avLst/>
+          </a:prstGeom>
+          <a:solidFill>
+            <a:srgbClr val="FFFFFF"/>
+          </a:solidFill>
+          <a:ln w="12700">
+            <a:solidFill>
+              <a:srgbClr val="DDDDE7"/>
+            </a:solidFill>
+            <a:prstDash val="solid"/>
+          </a:ln>
+        </p:spPr>
+      </p:sp>
+      <p:sp>
+        <p:nvSpPr>
+          <p:cNvPr id="11" name="Text 9"/>
+          <p:cNvSpPr/>
+          <p:nvPr/>
+        </p:nvSpPr>
+        <p:spPr>
+          <a:xfrm>
+            <a:off x="7150608" y="1920240"/>
+            <a:ext cx="4206240" cy="731520"/>
+          </a:xfrm>
+          <a:prstGeom prst="rect">
+            <a:avLst/>
+          </a:prstGeom>
+          <a:noFill/>
+          <a:ln/>
+        </p:spPr>
+        <p:txBody>
+          <a:bodyPr wrap="square" lIns="0" tIns="0" rIns="0" bIns="0" rtlCol="0" anchor="ctr"/>
+          <a:lstStyle/>
+          <a:p>
+            <a:pPr indent="0" marL="0">
+              <a:lnSpc>
+                <a:spcPct val="110000"/>
+              </a:lnSpc>
+              <a:buNone/>
+            </a:pPr>
+            <a:r>
+              <a:rPr lang="en-US" sz="1050" dirty="0">
+                <a:solidFill>
+                  <a:srgbClr val="000B34"/>
+                </a:solidFill>
+                <a:latin typeface="Source Sans 3" pitchFamily="34" charset="0"/>
+                <a:ea typeface="Source Sans 3" pitchFamily="34" charset="-122"/>
+                <a:cs typeface="Source Sans 3" pitchFamily="34" charset="-120"/>
+              </a:rPr>
+              <a:t>Course planning: hub has My Course Planner; every faculty runs discipline-specific degree plans (heavy in the 1,150 CS pages). Two sources serving the same need — no connecting link between them.</a:t>
+            </a:r>
+            <a:endParaRPr lang="en-US" sz="1050" dirty="0"/>
+          </a:p>
+        </p:txBody>
+      </p:sp>
+      <p:sp>
+        <p:nvSpPr>
+          <p:cNvPr id="12" name="Shape 10"/>
+          <p:cNvSpPr/>
+          <p:nvPr/>
+        </p:nvSpPr>
+        <p:spPr>
+          <a:xfrm>
+            <a:off x="7022592" y="2743200"/>
+            <a:ext cx="4389120" cy="731520"/>
+          </a:xfrm>
+          <a:prstGeom prst="rect">
+            <a:avLst/>
+          </a:prstGeom>
+          <a:solidFill>
+            <a:srgbClr val="FFFFFF"/>
+          </a:solidFill>
+          <a:ln w="12700">
+            <a:solidFill>
+              <a:srgbClr val="DDDDE7"/>
+            </a:solidFill>
+            <a:prstDash val="solid"/>
+          </a:ln>
+        </p:spPr>
+      </p:sp>
+      <p:sp>
+        <p:nvSpPr>
+          <p:cNvPr id="13" name="Text 11"/>
+          <p:cNvSpPr/>
+          <p:nvPr/>
+        </p:nvSpPr>
+        <p:spPr>
+          <a:xfrm>
+            <a:off x="7150608" y="2743200"/>
+            <a:ext cx="4206240" cy="731520"/>
+          </a:xfrm>
+          <a:prstGeom prst="rect">
+            <a:avLst/>
+          </a:prstGeom>
+          <a:noFill/>
+          <a:ln/>
+        </p:spPr>
+        <p:txBody>
+          <a:bodyPr wrap="square" lIns="0" tIns="0" rIns="0" bIns="0" rtlCol="0" anchor="ctr"/>
+          <a:lstStyle/>
+          <a:p>
+            <a:pPr indent="0" marL="0">
+              <a:lnSpc>
+                <a:spcPct val="110000"/>
+              </a:lnSpc>
+              <a:buNone/>
+            </a:pPr>
+            <a:r>
+              <a:rPr lang="en-US" sz="1050" dirty="0">
+                <a:solidFill>
+                  <a:srgbClr val="000B34"/>
+                </a:solidFill>
+                <a:latin typeface="Source Sans 3" pitchFamily="34" charset="0"/>
+                <a:ea typeface="Source Sans 3" pitchFamily="34" charset="-122"/>
+                <a:cs typeface="Source Sans 3" pitchFamily="34" charset="-120"/>
+              </a:rPr>
+              <a:t>Placements &amp; WIL: 207 pages on faculty sites; hub has none. Students on clinical, practicum, studio or internship placements have no central entry point — they must find their faculty page first.</a:t>
+            </a:r>
+            <a:endParaRPr lang="en-US" sz="1050" dirty="0"/>
+          </a:p>
+        </p:txBody>
+      </p:sp>
+      <p:sp>
+        <p:nvSpPr>
+          <p:cNvPr id="14" name="Shape 12"/>
+          <p:cNvSpPr/>
+          <p:nvPr/>
+        </p:nvSpPr>
+        <p:spPr>
+          <a:xfrm>
+            <a:off x="7022592" y="3566160"/>
+            <a:ext cx="4389120" cy="731520"/>
+          </a:xfrm>
+          <a:prstGeom prst="rect">
+            <a:avLst/>
+          </a:prstGeom>
+          <a:solidFill>
+            <a:srgbClr val="FFFFFF"/>
+          </a:solidFill>
+          <a:ln w="12700">
+            <a:solidFill>
+              <a:srgbClr val="DDDDE7"/>
+            </a:solidFill>
+            <a:prstDash val="solid"/>
+          </a:ln>
+        </p:spPr>
+      </p:sp>
+      <p:sp>
+        <p:nvSpPr>
+          <p:cNvPr id="15" name="Text 13"/>
+          <p:cNvSpPr/>
+          <p:nvPr/>
+        </p:nvSpPr>
+        <p:spPr>
+          <a:xfrm>
+            <a:off x="7150608" y="3566160"/>
+            <a:ext cx="4206240" cy="731520"/>
+          </a:xfrm>
+          <a:prstGeom prst="rect">
+            <a:avLst/>
+          </a:prstGeom>
+          <a:noFill/>
+          <a:ln/>
+        </p:spPr>
+        <p:txBody>
+          <a:bodyPr wrap="square" lIns="0" tIns="0" rIns="0" bIns="0" rtlCol="0" anchor="ctr"/>
+          <a:lstStyle/>
+          <a:p>
+            <a:pPr indent="0" marL="0">
+              <a:lnSpc>
+                <a:spcPct val="110000"/>
+              </a:lnSpc>
+              <a:buNone/>
+            </a:pPr>
+            <a:r>
+              <a:rPr lang="en-US" sz="1050" dirty="0">
+                <a:solidFill>
+                  <a:srgbClr val="000B34"/>
+                </a:solidFill>
+                <a:latin typeface="Source Sans 3" pitchFamily="34" charset="0"/>
+                <a:ea typeface="Source Sans 3" pitchFamily="34" charset="-122"/>
+                <a:cs typeface="Source Sans 3" pitchFamily="34" charset="-120"/>
+              </a:rPr>
+              <a:t>Employability: hub Careers (11 pages) + 8 faculty services (141 pages) + study.unimelb (37 pages) + alumni mentoring (20 pages). Four presences in the estate, zero cross-links between them.</a:t>
+            </a:r>
+            <a:endParaRPr lang="en-US" sz="1050" dirty="0"/>
+          </a:p>
+        </p:txBody>
+      </p:sp>
+      <p:sp>
+        <p:nvSpPr>
+          <p:cNvPr id="16" name="Shape 14"/>
+          <p:cNvSpPr/>
+          <p:nvPr/>
+        </p:nvSpPr>
+        <p:spPr>
+          <a:xfrm>
+            <a:off x="7022592" y="4389120"/>
+            <a:ext cx="4389120" cy="731520"/>
+          </a:xfrm>
+          <a:prstGeom prst="rect">
+            <a:avLst/>
+          </a:prstGeom>
+          <a:solidFill>
+            <a:srgbClr val="FFFFFF"/>
+          </a:solidFill>
+          <a:ln w="12700">
+            <a:solidFill>
+              <a:srgbClr val="DDDDE7"/>
+            </a:solidFill>
+            <a:prstDash val="solid"/>
+          </a:ln>
+        </p:spPr>
+      </p:sp>
+      <p:sp>
+        <p:nvSpPr>
+          <p:cNvPr id="17" name="Text 15"/>
+          <p:cNvSpPr/>
+          <p:nvPr/>
+        </p:nvSpPr>
+        <p:spPr>
+          <a:xfrm>
+            <a:off x="7150608" y="4389120"/>
+            <a:ext cx="4206240" cy="731520"/>
+          </a:xfrm>
+          <a:prstGeom prst="rect">
+            <a:avLst/>
+          </a:prstGeom>
+          <a:noFill/>
+          <a:ln/>
+        </p:spPr>
+        <p:txBody>
+          <a:bodyPr wrap="square" lIns="0" tIns="0" rIns="0" bIns="0" rtlCol="0" anchor="ctr"/>
+          <a:lstStyle/>
+          <a:p>
+            <a:pPr indent="0" marL="0">
+              <a:lnSpc>
+                <a:spcPct val="110000"/>
+              </a:lnSpc>
+              <a:buNone/>
+            </a:pPr>
+            <a:r>
+              <a:rPr lang="en-US" sz="1050" dirty="0">
+                <a:solidFill>
+                  <a:srgbClr val="000B34"/>
+                </a:solidFill>
+                <a:latin typeface="Source Sans 3" pitchFamily="34" charset="0"/>
+                <a:ea typeface="Source Sans 3" pitchFamily="34" charset="-122"/>
+                <a:cs typeface="Source Sans 3" pitchFamily="34" charset="-120"/>
+              </a:rPr>
+              <a:t>Student life: hub covers UMSU/GSA (20 pages); faculties run their own enrichment programs; alumni.unimelb has 21 community pages. Three framings of campus experience with no connecting web path.</a:t>
+            </a:r>
+            <a:endParaRPr lang="en-US" sz="1050" dirty="0"/>
+          </a:p>
+        </p:txBody>
+      </p:sp>
+      <p:sp>
+        <p:nvSpPr>
+          <p:cNvPr id="18" name="Shape 16"/>
+          <p:cNvSpPr/>
+          <p:nvPr/>
+        </p:nvSpPr>
+        <p:spPr>
+          <a:xfrm>
+            <a:off x="7022592" y="5212080"/>
+            <a:ext cx="4389120" cy="731520"/>
+          </a:xfrm>
+          <a:prstGeom prst="rect">
+            <a:avLst/>
+          </a:prstGeom>
+          <a:solidFill>
+            <a:srgbClr val="FFFFFF"/>
+          </a:solidFill>
+          <a:ln w="12700">
+            <a:solidFill>
+              <a:srgbClr val="DDDDE7"/>
+            </a:solidFill>
+            <a:prstDash val="solid"/>
+          </a:ln>
+        </p:spPr>
+      </p:sp>
+      <p:sp>
+        <p:nvSpPr>
+          <p:cNvPr id="19" name="Text 17"/>
+          <p:cNvSpPr/>
+          <p:nvPr/>
+        </p:nvSpPr>
+        <p:spPr>
+          <a:xfrm>
+            <a:off x="7150608" y="5212080"/>
+            <a:ext cx="4206240" cy="731520"/>
+          </a:xfrm>
+          <a:prstGeom prst="rect">
+            <a:avLst/>
+          </a:prstGeom>
+          <a:noFill/>
+          <a:ln/>
+        </p:spPr>
+        <p:txBody>
+          <a:bodyPr wrap="square" lIns="0" tIns="0" rIns="0" bIns="0" rtlCol="0" anchor="ctr"/>
+          <a:lstStyle/>
+          <a:p>
+            <a:pPr indent="0" marL="0">
+              <a:lnSpc>
+                <a:spcPct val="110000"/>
+              </a:lnSpc>
+              <a:buNone/>
+            </a:pPr>
+            <a:r>
+              <a:rPr lang="en-US" sz="1050" dirty="0">
+                <a:solidFill>
+                  <a:srgbClr val="000B34"/>
+                </a:solidFill>
+                <a:latin typeface="Source Sans 3" pitchFamily="34" charset="0"/>
+                <a:ea typeface="Source Sans 3" pitchFamily="34" charset="-122"/>
+                <a:cs typeface="Source Sans 3" pitchFamily="34" charset="-120"/>
+              </a:rPr>
+              <a:t>Scholarships: 141 faculty pages + hub's generic 'Find a scholarship' link. scholarships.unimelb.edu.au is the dedicated entry point; none of the faculty CS pages link to it.</a:t>
+            </a:r>
+            <a:endParaRPr lang="en-US" sz="1050" dirty="0"/>
+          </a:p>
+        </p:txBody>
+      </p:sp>
+    </p:spTree>
+  </p:cSld>
+  <p:clrMapOvr>
+    <a:masterClrMapping/>
+  </p:clrMapOvr>
+</p:sld>
+</file>
+
+<file path=ppt/slides/slide8.xml><?xml version="1.0" encoding="utf-8"?>
+<p:sld xmlns:a="http://schemas.openxmlformats.org/drawingml/2006/main" xmlns:r="http://schemas.openxmlformats.org/officeDocument/2006/relationships" xmlns:p="http://schemas.openxmlformats.org/presentationml/2006/main">
+  <p:cSld name="Slide 8">
+    <p:bg>
+      <p:bgPr>
+        <a:solidFill>
+          <a:srgbClr val="FFFFFF"/>
+        </a:solidFill>
+      </p:bgPr>
+    </p:bg>
+    <p:spTree>
+      <p:nvGrpSpPr>
+        <p:cNvPr id="1" name=""/>
+        <p:cNvGrpSpPr/>
+        <p:nvPr/>
+      </p:nvGrpSpPr>
+      <p:grpSpPr>
+        <a:xfrm>
+          <a:off x="0" y="0"/>
+          <a:ext cx="0" cy="0"/>
+          <a:chOff x="0" y="0"/>
+          <a:chExt cx="0" cy="0"/>
+        </a:xfrm>
+      </p:grpSpPr>
+      <p:sp>
+        <p:nvSpPr>
+          <p:cNvPr id="2" name="Shape 0"/>
+          <p:cNvSpPr/>
+          <p:nvPr/>
+        </p:nvSpPr>
+        <p:spPr>
+          <a:xfrm>
+            <a:off x="548640" y="566928"/>
+            <a:ext cx="256032" cy="256032"/>
+          </a:xfrm>
+          <a:prstGeom prst="rect">
+            <a:avLst/>
+          </a:prstGeom>
+          <a:solidFill>
+            <a:srgbClr val="46C8F0"/>
+          </a:solidFill>
+          <a:ln/>
+        </p:spPr>
+      </p:sp>
+      <p:sp>
+        <p:nvSpPr>
+          <p:cNvPr id="3" name="Text 1"/>
+          <p:cNvSpPr/>
+          <p:nvPr/>
+        </p:nvSpPr>
+        <p:spPr>
+          <a:xfrm>
+            <a:off x="914400" y="457200"/>
+            <a:ext cx="10698480" cy="502920"/>
+          </a:xfrm>
+          <a:prstGeom prst="rect">
+            <a:avLst/>
+          </a:prstGeom>
+          <a:noFill/>
+          <a:ln/>
+        </p:spPr>
+        <p:txBody>
+          <a:bodyPr wrap="square" lIns="0" tIns="0" rIns="0" bIns="0" rtlCol="0" anchor="ctr"/>
+          <a:lstStyle/>
+          <a:p>
+            <a:pPr indent="0" marL="0">
+              <a:buNone/>
+            </a:pPr>
+            <a:r>
+              <a:rPr lang="en-US" sz="2900" b="1" dirty="0">
+                <a:solidFill>
+                  <a:srgbClr val="000F46"/>
+                </a:solidFill>
+                <a:latin typeface="Fraunces" pitchFamily="34" charset="0"/>
+                <a:ea typeface="Fraunces" pitchFamily="34" charset="-122"/>
+                <a:cs typeface="Fraunces" pitchFamily="34" charset="-120"/>
+              </a:rPr>
+              <a:t>What's already in flight</a:t>
+            </a:r>
+            <a:endParaRPr lang="en-US" sz="2900" dirty="0"/>
+          </a:p>
+        </p:txBody>
+      </p:sp>
+      <p:sp>
+        <p:nvSpPr>
+          <p:cNvPr id="4" name="Text 2"/>
+          <p:cNvSpPr/>
+          <p:nvPr/>
+        </p:nvSpPr>
+        <p:spPr>
+          <a:xfrm>
+            <a:off x="548640" y="6437376"/>
+            <a:ext cx="9601200" cy="274320"/>
+          </a:xfrm>
+          <a:prstGeom prst="rect">
+            <a:avLst/>
+          </a:prstGeom>
+          <a:noFill/>
+          <a:ln/>
+        </p:spPr>
+        <p:txBody>
+          <a:bodyPr wrap="square" lIns="0" tIns="0" rIns="0" bIns="0" rtlCol="0" anchor="ctr"/>
+          <a:lstStyle/>
+          <a:p>
+            <a:pPr indent="0" marL="0">
+              <a:buNone/>
+            </a:pPr>
+            <a:r>
+              <a:rPr lang="en-US" sz="900" dirty="0">
+                <a:solidFill>
+                  <a:srgbClr val="5B5B6B"/>
+                </a:solidFill>
+                <a:latin typeface="Source Sans 3" pitchFamily="34" charset="0"/>
+                <a:ea typeface="Source Sans 3" pitchFamily="34" charset="-122"/>
+                <a:cs typeface="Source Sans 3" pitchFamily="34" charset="-120"/>
+              </a:rPr>
+              <a:t>University of Melbourne — web estate alignment discussion · for discussion</a:t>
+            </a:r>
+            <a:endParaRPr lang="en-US" sz="900" dirty="0"/>
+          </a:p>
+        </p:txBody>
+      </p:sp>
+      <p:sp>
+        <p:nvSpPr>
+          <p:cNvPr id="5" name="Text 3"/>
+          <p:cNvSpPr/>
+          <p:nvPr/>
+        </p:nvSpPr>
+        <p:spPr>
+          <a:xfrm>
+            <a:off x="11247120" y="6437376"/>
+            <a:ext cx="411480" cy="274320"/>
+          </a:xfrm>
+          <a:prstGeom prst="rect">
+            <a:avLst/>
+          </a:prstGeom>
+          <a:noFill/>
+          <a:ln/>
+        </p:spPr>
+        <p:txBody>
+          <a:bodyPr wrap="square" lIns="0" tIns="0" rIns="0" bIns="0" rtlCol="0" anchor="ctr"/>
+          <a:lstStyle/>
+          <a:p>
+            <a:pPr algn="r" indent="0" marL="0">
+              <a:buNone/>
+            </a:pPr>
+            <a:r>
+              <a:rPr lang="en-US" sz="900" dirty="0">
+                <a:solidFill>
+                  <a:srgbClr val="5B5B6B"/>
+                </a:solidFill>
+                <a:latin typeface="Source Sans 3" pitchFamily="34" charset="0"/>
+                <a:ea typeface="Source Sans 3" pitchFamily="34" charset="-122"/>
+                <a:cs typeface="Source Sans 3" pitchFamily="34" charset="-120"/>
+              </a:rPr>
+              <a:t>8</a:t>
+            </a:r>
+            <a:endParaRPr lang="en-US" sz="900" dirty="0"/>
+          </a:p>
+        </p:txBody>
+      </p:sp>
+      <p:sp>
+        <p:nvSpPr>
+          <p:cNvPr id="6" name="Text 4"/>
+          <p:cNvSpPr/>
+          <p:nvPr/>
+        </p:nvSpPr>
+        <p:spPr>
+          <a:xfrm>
+            <a:off x="566928" y="1325880"/>
             <a:ext cx="10881360" cy="457200"/>
           </a:xfrm>
           <a:prstGeom prst="rect">
@@ -16798,7 +17909,7 @@
       </p:sp>
       <p:graphicFrame>
         <p:nvGraphicFramePr>
-          <p:cNvPr id="8" name="Table 0"/>
+          <p:cNvPr id="9" name="Table 0"/>
           <p:cNvGraphicFramePr>
             <a:graphicFrameLocks noGrp="1"/>
           </p:cNvGraphicFramePr>
@@ -18118,9 +19229,9 @@
 </p:sld>
 </file>
 
-<file path=ppt/slides/slide8.xml><?xml version="1.0" encoding="utf-8"?>
+<file path=ppt/slides/slide9.xml><?xml version="1.0" encoding="utf-8"?>
 <p:sld xmlns:a="http://schemas.openxmlformats.org/drawingml/2006/main" xmlns:r="http://schemas.openxmlformats.org/officeDocument/2006/relationships" xmlns:p="http://schemas.openxmlformats.org/presentationml/2006/main">
-  <p:cSld name="Slide 8">
+  <p:cSld name="Slide 9">
     <p:bg>
       <p:bgPr>
         <a:solidFill>
@@ -18273,7 +19384,7 @@
                 <a:ea typeface="Source Sans 3" pitchFamily="34" charset="-122"/>
                 <a:cs typeface="Source Sans 3" pitchFamily="34" charset="-120"/>
               </a:rPr>
-              <a:t>8</a:t>
+              <a:t>9</a:t>
             </a:r>
             <a:endParaRPr lang="en-US" sz="900" dirty="0"/>
           </a:p>
@@ -18653,311 +19764,6 @@
             <a:prstDash val="solid"/>
           </a:ln>
         </p:spPr>
-      </p:sp>
-    </p:spTree>
-  </p:cSld>
-  <p:clrMapOvr>
-    <a:masterClrMapping/>
-  </p:clrMapOvr>
-</p:sld>
-</file>
-
-<file path=ppt/slides/slide9.xml><?xml version="1.0" encoding="utf-8"?>
-<p:sld xmlns:a="http://schemas.openxmlformats.org/drawingml/2006/main" xmlns:r="http://schemas.openxmlformats.org/officeDocument/2006/relationships" xmlns:p="http://schemas.openxmlformats.org/presentationml/2006/main">
-  <p:cSld name="Slide 9">
-    <p:bg>
-      <p:bgPr>
-        <a:solidFill>
-          <a:srgbClr val="000F46"/>
-        </a:solidFill>
-      </p:bgPr>
-    </p:bg>
-    <p:spTree>
-      <p:nvGrpSpPr>
-        <p:cNvPr id="1" name=""/>
-        <p:cNvGrpSpPr/>
-        <p:nvPr/>
-      </p:nvGrpSpPr>
-      <p:grpSpPr>
-        <a:xfrm>
-          <a:off x="0" y="0"/>
-          <a:ext cx="0" cy="0"/>
-          <a:chOff x="0" y="0"/>
-          <a:chExt cx="0" cy="0"/>
-        </a:xfrm>
-      </p:grpSpPr>
-      <p:sp>
-        <p:nvSpPr>
-          <p:cNvPr id="2" name="Shape 0"/>
-          <p:cNvSpPr/>
-          <p:nvPr/>
-        </p:nvSpPr>
-        <p:spPr>
-          <a:xfrm>
-            <a:off x="566928" y="658368"/>
-            <a:ext cx="274320" cy="274320"/>
-          </a:xfrm>
-          <a:prstGeom prst="rect">
-            <a:avLst/>
-          </a:prstGeom>
-          <a:solidFill>
-            <a:srgbClr val="46C8F0"/>
-          </a:solidFill>
-          <a:ln/>
-        </p:spPr>
-      </p:sp>
-      <p:sp>
-        <p:nvSpPr>
-          <p:cNvPr id="3" name="Text 1"/>
-          <p:cNvSpPr/>
-          <p:nvPr/>
-        </p:nvSpPr>
-        <p:spPr>
-          <a:xfrm>
-            <a:off x="969264" y="548640"/>
-            <a:ext cx="10058400" cy="640080"/>
-          </a:xfrm>
-          <a:prstGeom prst="rect">
-            <a:avLst/>
-          </a:prstGeom>
-          <a:noFill/>
-          <a:ln/>
-        </p:spPr>
-        <p:txBody>
-          <a:bodyPr wrap="square" lIns="0" tIns="0" rIns="0" bIns="0" rtlCol="0" anchor="ctr"/>
-          <a:lstStyle/>
-          <a:p>
-            <a:pPr indent="0" marL="0">
-              <a:buNone/>
-            </a:pPr>
-            <a:r>
-              <a:rPr lang="en-US" sz="3200" b="1" dirty="0">
-                <a:solidFill>
-                  <a:srgbClr val="FFFFFF"/>
-                </a:solidFill>
-                <a:latin typeface="Fraunces" pitchFamily="34" charset="0"/>
-                <a:ea typeface="Fraunces" pitchFamily="34" charset="-122"/>
-                <a:cs typeface="Fraunces" pitchFamily="34" charset="-120"/>
-              </a:rPr>
-              <a:t>Where to from here — together</a:t>
-            </a:r>
-            <a:endParaRPr lang="en-US" sz="3200" dirty="0"/>
-          </a:p>
-        </p:txBody>
-      </p:sp>
-      <p:sp>
-        <p:nvSpPr>
-          <p:cNvPr id="4" name="Text 2"/>
-          <p:cNvSpPr/>
-          <p:nvPr/>
-        </p:nvSpPr>
-        <p:spPr>
-          <a:xfrm>
-            <a:off x="585216" y="1508760"/>
-            <a:ext cx="10058400" cy="457200"/>
-          </a:xfrm>
-          <a:prstGeom prst="rect">
-            <a:avLst/>
-          </a:prstGeom>
-          <a:noFill/>
-          <a:ln/>
-        </p:spPr>
-        <p:txBody>
-          <a:bodyPr wrap="square" lIns="0" tIns="0" rIns="0" bIns="0" rtlCol="0" anchor="ctr"/>
-          <a:lstStyle/>
-          <a:p>
-            <a:pPr indent="0" marL="0">
-              <a:buNone/>
-            </a:pPr>
-            <a:r>
-              <a:rPr lang="en-US" sz="1700" i="1" dirty="0">
-                <a:solidFill>
-                  <a:srgbClr val="46C8F0"/>
-                </a:solidFill>
-                <a:latin typeface="Source Sans 3" pitchFamily="34" charset="0"/>
-                <a:ea typeface="Source Sans 3" pitchFamily="34" charset="-122"/>
-                <a:cs typeface="Source Sans 3" pitchFamily="34" charset="-120"/>
-              </a:rPr>
-              <a:t>Not conclusions — questions to take forward.</a:t>
-            </a:r>
-            <a:endParaRPr lang="en-US" sz="1700" dirty="0"/>
-          </a:p>
-        </p:txBody>
-      </p:sp>
-      <p:sp>
-        <p:nvSpPr>
-          <p:cNvPr id="5" name="Text 3"/>
-          <p:cNvSpPr/>
-          <p:nvPr/>
-        </p:nvSpPr>
-        <p:spPr>
-          <a:xfrm>
-            <a:off x="603504" y="2286000"/>
-            <a:ext cx="10424160" cy="3291840"/>
-          </a:xfrm>
-          <a:prstGeom prst="rect">
-            <a:avLst/>
-          </a:prstGeom>
-          <a:noFill/>
-          <a:ln/>
-        </p:spPr>
-        <p:txBody>
-          <a:bodyPr wrap="square" lIns="0" tIns="0" rIns="0" bIns="0" rtlCol="0" anchor="t"/>
-          <a:lstStyle/>
-          <a:p>
-            <a:pPr marL="228600" indent="-228600">
-              <a:spcAft>
-                <a:spcPts val="1600"/>
-              </a:spcAft>
-              <a:buSzPct val="100000"/>
-              <a:buChar char="•"/>
-            </a:pPr>
-            <a:r>
-              <a:rPr lang="en-US" sz="1800" dirty="0">
-                <a:solidFill>
-                  <a:srgbClr val="FFFFFF"/>
-                </a:solidFill>
-                <a:latin typeface="Source Sans 3" pitchFamily="34" charset="0"/>
-                <a:ea typeface="Source Sans 3" pitchFamily="34" charset="-122"/>
-                <a:cs typeface="Source Sans 3" pitchFamily="34" charset="-120"/>
-              </a:rPr>
-              <a:t>Across all areas: what did we agree are the real overlaps?</a:t>
-            </a:r>
-            <a:endParaRPr lang="en-US" sz="1800" dirty="0"/>
-          </a:p>
-          <a:p>
-            <a:pPr marL="228600" indent="-228600">
-              <a:spcAft>
-                <a:spcPts val="1600"/>
-              </a:spcAft>
-              <a:buSzPct val="100000"/>
-              <a:buChar char="•"/>
-            </a:pPr>
-            <a:r>
-              <a:rPr lang="en-US" sz="1800" dirty="0">
-                <a:solidFill>
-                  <a:srgbClr val="FFFFFF"/>
-                </a:solidFill>
-                <a:latin typeface="Source Sans 3" pitchFamily="34" charset="0"/>
-                <a:ea typeface="Source Sans 3" pitchFamily="34" charset="-122"/>
-                <a:cs typeface="Source Sans 3" pitchFamily="34" charset="-120"/>
-              </a:rPr>
-              <a:t>What is already in flight that we could connect or build on?</a:t>
-            </a:r>
-            <a:endParaRPr lang="en-US" sz="1800" dirty="0"/>
-          </a:p>
-          <a:p>
-            <a:pPr marL="228600" indent="-228600">
-              <a:spcAft>
-                <a:spcPts val="1600"/>
-              </a:spcAft>
-              <a:buSzPct val="100000"/>
-              <a:buChar char="•"/>
-            </a:pPr>
-            <a:r>
-              <a:rPr lang="en-US" sz="1800" dirty="0">
-                <a:solidFill>
-                  <a:srgbClr val="FFFFFF"/>
-                </a:solidFill>
-                <a:latin typeface="Source Sans 3" pitchFamily="34" charset="0"/>
-                <a:ea typeface="Source Sans 3" pitchFamily="34" charset="-122"/>
-                <a:cs typeface="Source Sans 3" pitchFamily="34" charset="-120"/>
-              </a:rPr>
-              <a:t>For the biggest overlap — what is one next step, and who is involved?</a:t>
-            </a:r>
-            <a:endParaRPr lang="en-US" sz="1800" dirty="0"/>
-          </a:p>
-          <a:p>
-            <a:pPr marL="228600" indent="-228600">
-              <a:spcAft>
-                <a:spcPts val="1600"/>
-              </a:spcAft>
-              <a:buSzPct val="100000"/>
-              <a:buChar char="•"/>
-            </a:pPr>
-            <a:r>
-              <a:rPr lang="en-US" sz="1800" dirty="0">
-                <a:solidFill>
-                  <a:srgbClr val="FFFFFF"/>
-                </a:solidFill>
-                <a:latin typeface="Source Sans 3" pitchFamily="34" charset="0"/>
-                <a:ea typeface="Source Sans 3" pitchFamily="34" charset="-122"/>
-                <a:cs typeface="Source Sans 3" pitchFamily="34" charset="-120"/>
-              </a:rPr>
-              <a:t>How will we keep aligned as this work continues?</a:t>
-            </a:r>
-            <a:endParaRPr lang="en-US" sz="1800" dirty="0"/>
-          </a:p>
-        </p:txBody>
-      </p:sp>
-      <p:pic>
-        <p:nvPicPr>
-          <p:cNvPr id="6" name="Image 0" descr="/Users/djmulholland/Documents/Claude/projects/unimelb-current-students-ia/discussion-deck/assets/logo-white.svg">    </p:cNvPr>
-          <p:cNvPicPr>
-            <a:picLocks noChangeAspect="1"/>
-          </p:cNvPicPr>
-          <p:nvPr/>
-        </p:nvPicPr>
-        <p:blipFill>
-          <a:blip r:embed="rId1">
-            <a:extLst>
-              <a:ext uri="{96DAC541-7B7A-43D3-8B79-37D633B846F1}">
-                <asvg:svgBlip xmlns:asvg="http://schemas.microsoft.com/office/drawing/2016/SVG/main" r:embed="rId2"/>
-              </a:ext>
-            </a:extLst>
-          </a:blip>
-          <a:stretch>
-            <a:fillRect/>
-          </a:stretch>
-        </p:blipFill>
-        <p:spPr>
-          <a:xfrm>
-            <a:off x="9601200" y="6053328"/>
-            <a:ext cx="2011680" cy="632143"/>
-          </a:xfrm>
-          <a:prstGeom prst="rect">
-            <a:avLst/>
-          </a:prstGeom>
-        </p:spPr>
-      </p:pic>
-      <p:sp>
-        <p:nvSpPr>
-          <p:cNvPr id="7" name="Text 4"/>
-          <p:cNvSpPr/>
-          <p:nvPr/>
-        </p:nvSpPr>
-        <p:spPr>
-          <a:xfrm>
-            <a:off x="603504" y="6217920"/>
-            <a:ext cx="5486400" cy="365760"/>
-          </a:xfrm>
-          <a:prstGeom prst="rect">
-            <a:avLst/>
-          </a:prstGeom>
-          <a:noFill/>
-          <a:ln/>
-        </p:spPr>
-        <p:txBody>
-          <a:bodyPr wrap="square" lIns="0" tIns="0" rIns="0" bIns="0" rtlCol="0" anchor="ctr"/>
-          <a:lstStyle/>
-          <a:p>
-            <a:pPr indent="0" marL="0">
-              <a:buNone/>
-            </a:pPr>
-            <a:r>
-              <a:rPr lang="en-US" sz="1200" dirty="0">
-                <a:solidFill>
-                  <a:srgbClr val="C9CDE6"/>
-                </a:solidFill>
-                <a:latin typeface="Source Code Pro" pitchFamily="34" charset="0"/>
-                <a:ea typeface="Source Code Pro" pitchFamily="34" charset="-122"/>
-                <a:cs typeface="Source Code Pro" pitchFamily="34" charset="-120"/>
-              </a:rPr>
-              <a:t>Thank you · discussion</a:t>
-            </a:r>
-            <a:endParaRPr lang="en-US" sz="1200" dirty="0"/>
-          </a:p>
-        </p:txBody>
       </p:sp>
     </p:spTree>
   </p:cSld>

</xml_diff>

<commit_message>
feat: full-faculty context analysis + cleaned-data pipeline, refreshed reports
- data/clean/: reproducible build_clean_dataset.py (corrections D1–D14) and
  full_faculty_stats.py; cleaned count tables replace the hand-built CSVs
- analysis: new full-faculty-context.md — full-domain crawl of all 9 faculty
  sites (2,363 pages) shows current students are a ~7% sign-posted tenant with
  no shared faculty IA; structural-findings.md gains Finding 27; data-and-
  synthesis-issues.md added; terminology swept hub -> students.unimelb.edu.au
- report: DEAG pack gains Finding 10; recommendations threaded with the
  denominator; HTML+PDF regenerated (DEAG, Recommendations, Topic Deep-Dives)
- discussion-deck: build-v2.js + deck v2 (cleaned counts + terminology); v1 kept
- crawl: processed full-domain crawls (crawl/full-faculty/*.json) + crawler scripts
- chore: add .gitignore; untrack regenerable graphify-out/ cache and .DS_Store

Co-Authored-By: Claude Opus 4.8 <noreply@anthropic.com>
</commit_message>
<xml_diff>
--- a/discussion-deck/Current-Students-EndToEnd-Discussion.pptx
+++ b/discussion-deck/Current-Students-EndToEnd-Discussion.pptx
@@ -17425,7 +17425,7 @@
                 <a:ea typeface="Source Sans 3" pitchFamily="34" charset="-122"/>
                 <a:cs typeface="Source Sans 3" pitchFamily="34" charset="-120"/>
               </a:rPr>
-              <a:t>Course planning: hub has My Course Planner; every faculty runs discipline-specific degree plans (heavy in the 1,150 CS pages). Two sources serving the same need — no connecting link between them.</a:t>
+              <a:t>Course planning: hub has My Course Planner; FEIT re-hosts it verbatim on its own site. Every faculty also runs its own degree plans across the 1,150 CS pages. Same tool, same content, no connecting link between any of them.</a:t>
             </a:r>
             <a:endParaRPr lang="en-US" sz="1050" dirty="0"/>
           </a:p>
@@ -17492,7 +17492,7 @@
                 <a:ea typeface="Source Sans 3" pitchFamily="34" charset="-122"/>
                 <a:cs typeface="Source Sans 3" pitchFamily="34" charset="-120"/>
               </a:rPr>
-              <a:t>Placements &amp; WIL: 207 pages on faculty sites; hub has none. Students on clinical, practicum, studio or internship placements have no central entry point — they must find their faculty page first.</a:t>
+              <a:t>Placements &amp; WIL: 206 pages across all faculties (MDHS alone holds 96, nearly all clinical compliance); hub has none. No central WIL gateway — students cannot discover faculty placement offerings from the centre.</a:t>
             </a:r>
             <a:endParaRPr lang="en-US" sz="1050" dirty="0"/>
           </a:p>
@@ -17559,7 +17559,7 @@
                 <a:ea typeface="Source Sans 3" pitchFamily="34" charset="-122"/>
                 <a:cs typeface="Source Sans 3" pitchFamily="34" charset="-120"/>
               </a:rPr>
-              <a:t>Employability: hub Careers (11 pages) + 8 faculty services (141 pages) + study.unimelb (37 pages) + alumni mentoring (20 pages). Four presences in the estate, zero cross-links between them.</a:t>
+              <a:t>Employability: 7 faculties each run a near-identical 'Employability in X' page restating the same central careers service. Faculty-owned core — regulated pathways, internship subjects, teacher registration — is sound; the template duplication is the problem.</a:t>
             </a:r>
             <a:endParaRPr lang="en-US" sz="1050" dirty="0"/>
           </a:p>

</xml_diff>